<commit_message>
docs: entregable con diccionario de datos, capas mvc y generadores versionados
Co-Authored-By: Claude Opus 5.5 <noreply@anthropic.com>
Claude-Session: https://claude.ai/code/session_01TmPLmdbHXmm4KrQvJaZQ7C
</commit_message>
<xml_diff>
--- a/docs/entregable-parte-1/presentacion.pptx
+++ b/docs/entregable-parte-1/presentacion.pptx
@@ -2326,7 +2326,7 @@
                 <a:ea typeface="Calibri" pitchFamily="34" charset="-122"/>
                 <a:cs typeface="Calibri" pitchFamily="34" charset="-120"/>
               </a:rPr>
-              <a:t>Libro de movimientos, facturas y notas de crédito</a:t>
+              <a:t>Libro de inventario, facturas y notas</a:t>
             </a:r>
             <a:endParaRPr lang="en-US" sz="1200" dirty="0"/>
           </a:p>
@@ -5753,44 +5753,638 @@
           </a:p>
         </p:txBody>
       </p:sp>
-      <p:pic>
-        <p:nvPicPr>
-          <p:cNvPr id="4" name="Image 0" descr="diagramas/arquitectura.png">    </p:cNvPr>
-          <p:cNvPicPr>
-            <a:picLocks noChangeAspect="1"/>
-          </p:cNvPicPr>
-          <p:nvPr/>
-        </p:nvPicPr>
-        <p:blipFill>
-          <a:blip r:embed="rId1"/>
-          <a:stretch>
-            <a:fillRect/>
-          </a:stretch>
-        </p:blipFill>
-        <p:spPr>
-          <a:xfrm>
-            <a:off x="457200" y="1280160"/>
-            <a:ext cx="8229600" cy="1595496"/>
-          </a:xfrm>
-          <a:prstGeom prst="rect">
-            <a:avLst/>
-          </a:prstGeom>
-        </p:spPr>
-      </p:pic>
-      <p:sp>
-        <p:nvSpPr>
-          <p:cNvPr id="5" name="Shape 2"/>
+      <p:sp>
+        <p:nvSpPr>
+          <p:cNvPr id="4" name="Shape 2"/>
           <p:cNvSpPr/>
           <p:nvPr/>
         </p:nvSpPr>
         <p:spPr>
           <a:xfrm>
-            <a:off x="457200" y="3195696"/>
-            <a:ext cx="2606040" cy="1559184"/>
+            <a:off x="457200" y="1234440"/>
+            <a:ext cx="3291840" cy="457200"/>
           </a:xfrm>
           <a:prstGeom prst="roundRect">
             <a:avLst>
-              <a:gd name="adj" fmla="val 4692"/>
+              <a:gd name="adj" fmla="val 12000"/>
+            </a:avLst>
+          </a:prstGeom>
+          <a:solidFill>
+            <a:srgbClr val="E8EEFC"/>
+          </a:solidFill>
+          <a:ln w="12700">
+            <a:solidFill>
+              <a:srgbClr val="C7D2EA"/>
+            </a:solidFill>
+            <a:prstDash val="solid"/>
+          </a:ln>
+        </p:spPr>
+      </p:sp>
+      <p:sp>
+        <p:nvSpPr>
+          <p:cNvPr id="5" name="Text 3"/>
+          <p:cNvSpPr txBox="1"/>
+          <p:nvPr/>
+        </p:nvSpPr>
+        <p:spPr>
+          <a:xfrm>
+            <a:off x="548640" y="1234440"/>
+            <a:ext cx="3108960" cy="457200"/>
+          </a:xfrm>
+          <a:prstGeom prst="rect">
+            <a:avLst/>
+          </a:prstGeom>
+          <a:noFill/>
+          <a:ln/>
+        </p:spPr>
+        <p:txBody>
+          <a:bodyPr wrap="square" lIns="0" tIns="0" rIns="0" bIns="0" rtlCol="0" anchor="ctr"/>
+          <a:lstStyle/>
+          <a:p>
+            <a:pPr algn="ctr" indent="0" marL="0">
+              <a:buNone/>
+            </a:pPr>
+            <a:r>
+              <a:rPr lang="en-US" sz="1200" b="1" dirty="0">
+                <a:solidFill>
+                  <a:srgbClr val="14213D"/>
+                </a:solidFill>
+                <a:latin typeface="Calibri" pitchFamily="34" charset="0"/>
+                <a:ea typeface="Calibri" pitchFamily="34" charset="-122"/>
+                <a:cs typeface="Calibri" pitchFamily="34" charset="-120"/>
+              </a:rPr>
+              <a:t>Usuario (navegador)</a:t>
+            </a:r>
+            <a:endParaRPr lang="en-US" sz="1200" dirty="0"/>
+          </a:p>
+          <a:p>
+            <a:pPr algn="ctr" indent="0" marL="0">
+              <a:buNone/>
+            </a:pPr>
+            <a:r>
+              <a:rPr lang="en-US" sz="1000" dirty="0">
+                <a:solidFill>
+                  <a:srgbClr val="5B6475"/>
+                </a:solidFill>
+                <a:latin typeface="Calibri" pitchFamily="34" charset="0"/>
+                <a:ea typeface="Calibri" pitchFamily="34" charset="-122"/>
+                <a:cs typeface="Calibri" pitchFamily="34" charset="-120"/>
+              </a:rPr>
+              <a:t>GET/POST HTML · cookie HttpOnly</a:t>
+            </a:r>
+            <a:endParaRPr lang="en-US" sz="1200" dirty="0"/>
+          </a:p>
+        </p:txBody>
+      </p:sp>
+      <p:sp>
+        <p:nvSpPr>
+          <p:cNvPr id="6" name="Shape 4"/>
+          <p:cNvSpPr/>
+          <p:nvPr/>
+        </p:nvSpPr>
+        <p:spPr>
+          <a:xfrm>
+            <a:off x="2103120" y="1691640"/>
+            <a:ext cx="0" cy="146304"/>
+          </a:xfrm>
+          <a:prstGeom prst="line">
+            <a:avLst/>
+          </a:prstGeom>
+          <a:noFill/>
+          <a:ln w="19050">
+            <a:solidFill>
+              <a:srgbClr val="2155D9"/>
+            </a:solidFill>
+            <a:prstDash val="solid"/>
+            <a:tailEnd type="triangle"/>
+          </a:ln>
+        </p:spPr>
+      </p:sp>
+      <p:sp>
+        <p:nvSpPr>
+          <p:cNvPr id="7" name="Shape 5"/>
+          <p:cNvSpPr/>
+          <p:nvPr/>
+        </p:nvSpPr>
+        <p:spPr>
+          <a:xfrm>
+            <a:off x="457200" y="1837944"/>
+            <a:ext cx="3291840" cy="457200"/>
+          </a:xfrm>
+          <a:prstGeom prst="roundRect">
+            <a:avLst>
+              <a:gd name="adj" fmla="val 12000"/>
+            </a:avLst>
+          </a:prstGeom>
+          <a:solidFill>
+            <a:srgbClr val="E8EEFC"/>
+          </a:solidFill>
+          <a:ln w="12700">
+            <a:solidFill>
+              <a:srgbClr val="C7D2EA"/>
+            </a:solidFill>
+            <a:prstDash val="solid"/>
+          </a:ln>
+        </p:spPr>
+      </p:sp>
+      <p:sp>
+        <p:nvSpPr>
+          <p:cNvPr id="8" name="Text 6"/>
+          <p:cNvSpPr txBox="1"/>
+          <p:nvPr/>
+        </p:nvSpPr>
+        <p:spPr>
+          <a:xfrm>
+            <a:off x="548640" y="1837944"/>
+            <a:ext cx="3108960" cy="457200"/>
+          </a:xfrm>
+          <a:prstGeom prst="rect">
+            <a:avLst/>
+          </a:prstGeom>
+          <a:noFill/>
+          <a:ln/>
+        </p:spPr>
+        <p:txBody>
+          <a:bodyPr wrap="square" lIns="0" tIns="0" rIns="0" bIns="0" rtlCol="0" anchor="ctr"/>
+          <a:lstStyle/>
+          <a:p>
+            <a:pPr algn="ctr" indent="0" marL="0">
+              <a:buNone/>
+            </a:pPr>
+            <a:r>
+              <a:rPr lang="en-US" sz="1200" b="1" dirty="0">
+                <a:solidFill>
+                  <a:srgbClr val="14213D"/>
+                </a:solidFill>
+                <a:latin typeface="Calibri" pitchFamily="34" charset="0"/>
+                <a:ea typeface="Calibri" pitchFamily="34" charset="-122"/>
+                <a:cs typeface="Calibri" pitchFamily="34" charset="-120"/>
+              </a:rPr>
+              <a:t>OpenSource1.Blazor</a:t>
+            </a:r>
+            <a:endParaRPr lang="en-US" sz="1200" dirty="0"/>
+          </a:p>
+          <a:p>
+            <a:pPr algn="ctr" indent="0" marL="0">
+              <a:buNone/>
+            </a:pPr>
+            <a:r>
+              <a:rPr lang="en-US" sz="1000" dirty="0">
+                <a:solidFill>
+                  <a:srgbClr val="5B6475"/>
+                </a:solidFill>
+                <a:latin typeface="Calibri" pitchFamily="34" charset="0"/>
+                <a:ea typeface="Calibri" pitchFamily="34" charset="-122"/>
+                <a:cs typeface="Calibri" pitchFamily="34" charset="-120"/>
+              </a:rPr>
+              <a:t>Static SSR · cliente HTTP tipado</a:t>
+            </a:r>
+            <a:endParaRPr lang="en-US" sz="1200" dirty="0"/>
+          </a:p>
+        </p:txBody>
+      </p:sp>
+      <p:sp>
+        <p:nvSpPr>
+          <p:cNvPr id="9" name="Shape 7"/>
+          <p:cNvSpPr/>
+          <p:nvPr/>
+        </p:nvSpPr>
+        <p:spPr>
+          <a:xfrm>
+            <a:off x="2103120" y="2295144"/>
+            <a:ext cx="0" cy="146304"/>
+          </a:xfrm>
+          <a:prstGeom prst="line">
+            <a:avLst/>
+          </a:prstGeom>
+          <a:noFill/>
+          <a:ln w="19050">
+            <a:solidFill>
+              <a:srgbClr val="2155D9"/>
+            </a:solidFill>
+            <a:prstDash val="solid"/>
+            <a:tailEnd type="triangle"/>
+          </a:ln>
+        </p:spPr>
+      </p:sp>
+      <p:sp>
+        <p:nvSpPr>
+          <p:cNvPr id="10" name="Shape 8"/>
+          <p:cNvSpPr/>
+          <p:nvPr/>
+        </p:nvSpPr>
+        <p:spPr>
+          <a:xfrm>
+            <a:off x="457200" y="2441448"/>
+            <a:ext cx="3291840" cy="457200"/>
+          </a:xfrm>
+          <a:prstGeom prst="roundRect">
+            <a:avLst>
+              <a:gd name="adj" fmla="val 12000"/>
+            </a:avLst>
+          </a:prstGeom>
+          <a:solidFill>
+            <a:srgbClr val="E8EEFC"/>
+          </a:solidFill>
+          <a:ln w="12700">
+            <a:solidFill>
+              <a:srgbClr val="C7D2EA"/>
+            </a:solidFill>
+            <a:prstDash val="solid"/>
+          </a:ln>
+        </p:spPr>
+      </p:sp>
+      <p:sp>
+        <p:nvSpPr>
+          <p:cNvPr id="11" name="Text 9"/>
+          <p:cNvSpPr txBox="1"/>
+          <p:nvPr/>
+        </p:nvSpPr>
+        <p:spPr>
+          <a:xfrm>
+            <a:off x="548640" y="2441448"/>
+            <a:ext cx="3108960" cy="457200"/>
+          </a:xfrm>
+          <a:prstGeom prst="rect">
+            <a:avLst/>
+          </a:prstGeom>
+          <a:noFill/>
+          <a:ln/>
+        </p:spPr>
+        <p:txBody>
+          <a:bodyPr wrap="square" lIns="0" tIns="0" rIns="0" bIns="0" rtlCol="0" anchor="ctr"/>
+          <a:lstStyle/>
+          <a:p>
+            <a:pPr algn="ctr" indent="0" marL="0">
+              <a:buNone/>
+            </a:pPr>
+            <a:r>
+              <a:rPr lang="en-US" sz="1200" b="1" dirty="0">
+                <a:solidFill>
+                  <a:srgbClr val="14213D"/>
+                </a:solidFill>
+                <a:latin typeface="Calibri" pitchFamily="34" charset="0"/>
+                <a:ea typeface="Calibri" pitchFamily="34" charset="-122"/>
+                <a:cs typeface="Calibri" pitchFamily="34" charset="-120"/>
+              </a:rPr>
+              <a:t>OpenSource1.Api</a:t>
+            </a:r>
+            <a:endParaRPr lang="en-US" sz="1200" dirty="0"/>
+          </a:p>
+          <a:p>
+            <a:pPr algn="ctr" indent="0" marL="0">
+              <a:buNone/>
+            </a:pPr>
+            <a:r>
+              <a:rPr lang="en-US" sz="1000" dirty="0">
+                <a:solidFill>
+                  <a:srgbClr val="5B6475"/>
+                </a:solidFill>
+                <a:latin typeface="Calibri" pitchFamily="34" charset="0"/>
+                <a:ea typeface="Calibri" pitchFamily="34" charset="-122"/>
+                <a:cs typeface="Calibri" pitchFamily="34" charset="-120"/>
+              </a:rPr>
+              <a:t>Controladores REST · JWT · políticas</a:t>
+            </a:r>
+            <a:endParaRPr lang="en-US" sz="1200" dirty="0"/>
+          </a:p>
+        </p:txBody>
+      </p:sp>
+      <p:sp>
+        <p:nvSpPr>
+          <p:cNvPr id="12" name="Shape 10"/>
+          <p:cNvSpPr/>
+          <p:nvPr/>
+        </p:nvSpPr>
+        <p:spPr>
+          <a:xfrm>
+            <a:off x="2103120" y="2898648"/>
+            <a:ext cx="0" cy="146304"/>
+          </a:xfrm>
+          <a:prstGeom prst="line">
+            <a:avLst/>
+          </a:prstGeom>
+          <a:noFill/>
+          <a:ln w="19050">
+            <a:solidFill>
+              <a:srgbClr val="2155D9"/>
+            </a:solidFill>
+            <a:prstDash val="solid"/>
+            <a:tailEnd type="triangle"/>
+          </a:ln>
+        </p:spPr>
+      </p:sp>
+      <p:sp>
+        <p:nvSpPr>
+          <p:cNvPr id="13" name="Shape 11"/>
+          <p:cNvSpPr/>
+          <p:nvPr/>
+        </p:nvSpPr>
+        <p:spPr>
+          <a:xfrm>
+            <a:off x="457200" y="3044952"/>
+            <a:ext cx="3291840" cy="457200"/>
+          </a:xfrm>
+          <a:prstGeom prst="roundRect">
+            <a:avLst>
+              <a:gd name="adj" fmla="val 12000"/>
+            </a:avLst>
+          </a:prstGeom>
+          <a:solidFill>
+            <a:srgbClr val="E8EEFC"/>
+          </a:solidFill>
+          <a:ln w="12700">
+            <a:solidFill>
+              <a:srgbClr val="C7D2EA"/>
+            </a:solidFill>
+            <a:prstDash val="solid"/>
+          </a:ln>
+        </p:spPr>
+      </p:sp>
+      <p:sp>
+        <p:nvSpPr>
+          <p:cNvPr id="14" name="Text 12"/>
+          <p:cNvSpPr txBox="1"/>
+          <p:nvPr/>
+        </p:nvSpPr>
+        <p:spPr>
+          <a:xfrm>
+            <a:off x="548640" y="3044952"/>
+            <a:ext cx="3108960" cy="457200"/>
+          </a:xfrm>
+          <a:prstGeom prst="rect">
+            <a:avLst/>
+          </a:prstGeom>
+          <a:noFill/>
+          <a:ln/>
+        </p:spPr>
+        <p:txBody>
+          <a:bodyPr wrap="square" lIns="0" tIns="0" rIns="0" bIns="0" rtlCol="0" anchor="ctr"/>
+          <a:lstStyle/>
+          <a:p>
+            <a:pPr algn="ctr" indent="0" marL="0">
+              <a:buNone/>
+            </a:pPr>
+            <a:r>
+              <a:rPr lang="en-US" sz="1200" b="1" dirty="0">
+                <a:solidFill>
+                  <a:srgbClr val="14213D"/>
+                </a:solidFill>
+                <a:latin typeface="Calibri" pitchFamily="34" charset="0"/>
+                <a:ea typeface="Calibri" pitchFamily="34" charset="-122"/>
+                <a:cs typeface="Calibri" pitchFamily="34" charset="-120"/>
+              </a:rPr>
+              <a:t>OpenSource1.Application</a:t>
+            </a:r>
+            <a:endParaRPr lang="en-US" sz="1200" dirty="0"/>
+          </a:p>
+          <a:p>
+            <a:pPr algn="ctr" indent="0" marL="0">
+              <a:buNone/>
+            </a:pPr>
+            <a:r>
+              <a:rPr lang="en-US" sz="1000" dirty="0">
+                <a:solidFill>
+                  <a:srgbClr val="5B6475"/>
+                </a:solidFill>
+                <a:latin typeface="Calibri" pitchFamily="34" charset="0"/>
+                <a:ea typeface="Calibri" pitchFamily="34" charset="-122"/>
+                <a:cs typeface="Calibri" pitchFamily="34" charset="-120"/>
+              </a:rPr>
+              <a:t>MediatR · validación · transacción</a:t>
+            </a:r>
+            <a:endParaRPr lang="en-US" sz="1200" dirty="0"/>
+          </a:p>
+        </p:txBody>
+      </p:sp>
+      <p:sp>
+        <p:nvSpPr>
+          <p:cNvPr id="15" name="Shape 13"/>
+          <p:cNvSpPr/>
+          <p:nvPr/>
+        </p:nvSpPr>
+        <p:spPr>
+          <a:xfrm>
+            <a:off x="2103120" y="3502152"/>
+            <a:ext cx="0" cy="146304"/>
+          </a:xfrm>
+          <a:prstGeom prst="line">
+            <a:avLst/>
+          </a:prstGeom>
+          <a:noFill/>
+          <a:ln w="19050">
+            <a:solidFill>
+              <a:srgbClr val="2155D9"/>
+            </a:solidFill>
+            <a:prstDash val="solid"/>
+            <a:tailEnd type="triangle"/>
+          </a:ln>
+        </p:spPr>
+      </p:sp>
+      <p:sp>
+        <p:nvSpPr>
+          <p:cNvPr id="16" name="Shape 14"/>
+          <p:cNvSpPr/>
+          <p:nvPr/>
+        </p:nvSpPr>
+        <p:spPr>
+          <a:xfrm>
+            <a:off x="457200" y="3648456"/>
+            <a:ext cx="3291840" cy="457200"/>
+          </a:xfrm>
+          <a:prstGeom prst="roundRect">
+            <a:avLst>
+              <a:gd name="adj" fmla="val 12000"/>
+            </a:avLst>
+          </a:prstGeom>
+          <a:solidFill>
+            <a:srgbClr val="E8EEFC"/>
+          </a:solidFill>
+          <a:ln w="12700">
+            <a:solidFill>
+              <a:srgbClr val="C7D2EA"/>
+            </a:solidFill>
+            <a:prstDash val="solid"/>
+          </a:ln>
+        </p:spPr>
+      </p:sp>
+      <p:sp>
+        <p:nvSpPr>
+          <p:cNvPr id="17" name="Text 15"/>
+          <p:cNvSpPr txBox="1"/>
+          <p:nvPr/>
+        </p:nvSpPr>
+        <p:spPr>
+          <a:xfrm>
+            <a:off x="548640" y="3648456"/>
+            <a:ext cx="3108960" cy="457200"/>
+          </a:xfrm>
+          <a:prstGeom prst="rect">
+            <a:avLst/>
+          </a:prstGeom>
+          <a:noFill/>
+          <a:ln/>
+        </p:spPr>
+        <p:txBody>
+          <a:bodyPr wrap="square" lIns="0" tIns="0" rIns="0" bIns="0" rtlCol="0" anchor="ctr"/>
+          <a:lstStyle/>
+          <a:p>
+            <a:pPr algn="ctr" indent="0" marL="0">
+              <a:buNone/>
+            </a:pPr>
+            <a:r>
+              <a:rPr lang="en-US" sz="1200" b="1" dirty="0">
+                <a:solidFill>
+                  <a:srgbClr val="14213D"/>
+                </a:solidFill>
+                <a:latin typeface="Calibri" pitchFamily="34" charset="0"/>
+                <a:ea typeface="Calibri" pitchFamily="34" charset="-122"/>
+                <a:cs typeface="Calibri" pitchFamily="34" charset="-120"/>
+              </a:rPr>
+              <a:t>OpenSource1.Infrastructure</a:t>
+            </a:r>
+            <a:endParaRPr lang="en-US" sz="1200" dirty="0"/>
+          </a:p>
+          <a:p>
+            <a:pPr algn="ctr" indent="0" marL="0">
+              <a:buNone/>
+            </a:pPr>
+            <a:r>
+              <a:rPr lang="en-US" sz="1000" dirty="0">
+                <a:solidFill>
+                  <a:srgbClr val="5B6475"/>
+                </a:solidFill>
+                <a:latin typeface="Calibri" pitchFamily="34" charset="0"/>
+                <a:ea typeface="Calibri" pitchFamily="34" charset="-122"/>
+                <a:cs typeface="Calibri" pitchFamily="34" charset="-120"/>
+              </a:rPr>
+              <a:t>EF Core (escritura) · Dapper (lectura)</a:t>
+            </a:r>
+            <a:endParaRPr lang="en-US" sz="1200" dirty="0"/>
+          </a:p>
+        </p:txBody>
+      </p:sp>
+      <p:sp>
+        <p:nvSpPr>
+          <p:cNvPr id="18" name="Shape 16"/>
+          <p:cNvSpPr/>
+          <p:nvPr/>
+        </p:nvSpPr>
+        <p:spPr>
+          <a:xfrm>
+            <a:off x="2103120" y="4105656"/>
+            <a:ext cx="0" cy="146304"/>
+          </a:xfrm>
+          <a:prstGeom prst="line">
+            <a:avLst/>
+          </a:prstGeom>
+          <a:noFill/>
+          <a:ln w="19050">
+            <a:solidFill>
+              <a:srgbClr val="2155D9"/>
+            </a:solidFill>
+            <a:prstDash val="solid"/>
+            <a:tailEnd type="triangle"/>
+          </a:ln>
+        </p:spPr>
+      </p:sp>
+      <p:sp>
+        <p:nvSpPr>
+          <p:cNvPr id="19" name="Shape 17"/>
+          <p:cNvSpPr/>
+          <p:nvPr/>
+        </p:nvSpPr>
+        <p:spPr>
+          <a:xfrm>
+            <a:off x="457200" y="4251960"/>
+            <a:ext cx="3291840" cy="457200"/>
+          </a:xfrm>
+          <a:prstGeom prst="roundRect">
+            <a:avLst>
+              <a:gd name="adj" fmla="val 12000"/>
+            </a:avLst>
+          </a:prstGeom>
+          <a:solidFill>
+            <a:srgbClr val="14213D"/>
+          </a:solidFill>
+          <a:ln w="12700">
+            <a:solidFill>
+              <a:srgbClr val="14213D"/>
+            </a:solidFill>
+            <a:prstDash val="solid"/>
+          </a:ln>
+        </p:spPr>
+      </p:sp>
+      <p:sp>
+        <p:nvSpPr>
+          <p:cNvPr id="20" name="Text 18"/>
+          <p:cNvSpPr txBox="1"/>
+          <p:nvPr/>
+        </p:nvSpPr>
+        <p:spPr>
+          <a:xfrm>
+            <a:off x="548640" y="4251960"/>
+            <a:ext cx="3108960" cy="457200"/>
+          </a:xfrm>
+          <a:prstGeom prst="rect">
+            <a:avLst/>
+          </a:prstGeom>
+          <a:noFill/>
+          <a:ln/>
+        </p:spPr>
+        <p:txBody>
+          <a:bodyPr wrap="square" lIns="0" tIns="0" rIns="0" bIns="0" rtlCol="0" anchor="ctr"/>
+          <a:lstStyle/>
+          <a:p>
+            <a:pPr algn="ctr" indent="0" marL="0">
+              <a:buNone/>
+            </a:pPr>
+            <a:r>
+              <a:rPr lang="en-US" sz="1200" b="1" dirty="0">
+                <a:solidFill>
+                  <a:srgbClr val="FFFFFF"/>
+                </a:solidFill>
+                <a:latin typeface="Calibri" pitchFamily="34" charset="0"/>
+                <a:ea typeface="Calibri" pitchFamily="34" charset="-122"/>
+                <a:cs typeface="Calibri" pitchFamily="34" charset="-120"/>
+              </a:rPr>
+              <a:t>PostgreSQL 17</a:t>
+            </a:r>
+            <a:endParaRPr lang="en-US" sz="1200" dirty="0"/>
+          </a:p>
+          <a:p>
+            <a:pPr algn="ctr" indent="0" marL="0">
+              <a:buNone/>
+            </a:pPr>
+            <a:r>
+              <a:rPr lang="en-US" sz="1000" dirty="0">
+                <a:solidFill>
+                  <a:srgbClr val="CADCFC"/>
+                </a:solidFill>
+                <a:latin typeface="Calibri" pitchFamily="34" charset="0"/>
+                <a:ea typeface="Calibri" pitchFamily="34" charset="-122"/>
+                <a:cs typeface="Calibri" pitchFamily="34" charset="-120"/>
+              </a:rPr>
+              <a:t>AxionERP_App · AxionERP_Identity</a:t>
+            </a:r>
+            <a:endParaRPr lang="en-US" sz="1200" dirty="0"/>
+          </a:p>
+        </p:txBody>
+      </p:sp>
+      <p:sp>
+        <p:nvSpPr>
+          <p:cNvPr id="21" name="Shape 19"/>
+          <p:cNvSpPr/>
+          <p:nvPr/>
+        </p:nvSpPr>
+        <p:spPr>
+          <a:xfrm>
+            <a:off x="4114800" y="1234440"/>
+            <a:ext cx="4572000" cy="1051560"/>
+          </a:xfrm>
+          <a:prstGeom prst="roundRect">
+            <a:avLst>
+              <a:gd name="adj" fmla="val 6957"/>
             </a:avLst>
           </a:prstGeom>
           <a:solidFill>
@@ -5806,14 +6400,14 @@
       </p:sp>
       <p:sp>
         <p:nvSpPr>
-          <p:cNvPr id="6" name="Text 3"/>
-          <p:cNvSpPr txBox="1"/>
-          <p:nvPr/>
-        </p:nvSpPr>
-        <p:spPr>
-          <a:xfrm>
-            <a:off x="640080" y="3305424"/>
-            <a:ext cx="2286000" cy="320040"/>
+          <p:cNvPr id="22" name="Text 20"/>
+          <p:cNvSpPr txBox="1"/>
+          <p:nvPr/>
+        </p:nvSpPr>
+        <p:spPr>
+          <a:xfrm>
+            <a:off x="4297680" y="1325880"/>
+            <a:ext cx="4206240" cy="292608"/>
           </a:xfrm>
           <a:prstGeom prst="rect">
             <a:avLst/>
@@ -5845,14 +6439,14 @@
       </p:sp>
       <p:sp>
         <p:nvSpPr>
-          <p:cNvPr id="7" name="Text 4"/>
-          <p:cNvSpPr txBox="1"/>
-          <p:nvPr/>
-        </p:nvSpPr>
-        <p:spPr>
-          <a:xfrm>
-            <a:off x="640080" y="3652896"/>
-            <a:ext cx="2286000" cy="1010544"/>
+          <p:cNvPr id="23" name="Text 21"/>
+          <p:cNvSpPr txBox="1"/>
+          <p:nvPr/>
+        </p:nvSpPr>
+        <p:spPr>
+          <a:xfrm>
+            <a:off x="4297680" y="1645920"/>
+            <a:ext cx="4206240" cy="566928"/>
           </a:xfrm>
           <a:prstGeom prst="rect">
             <a:avLst/>
@@ -5868,7 +6462,7 @@
               <a:buNone/>
             </a:pPr>
             <a:r>
-              <a:rPr lang="en-US" sz="1150" dirty="0">
+              <a:rPr lang="en-US" sz="1200" dirty="0">
                 <a:solidFill>
                   <a:srgbClr val="1F2937"/>
                 </a:solidFill>
@@ -5878,24 +6472,24 @@
               </a:rPr>
               <a:t>Blazor → cliente HTTP tipado → controlador → MediatR (Logging, Validation, Transaction) → EF Core / Dapper → PostgreSQL.</a:t>
             </a:r>
-            <a:endParaRPr lang="en-US" sz="1150" dirty="0"/>
-          </a:p>
-        </p:txBody>
-      </p:sp>
-      <p:sp>
-        <p:nvSpPr>
-          <p:cNvPr id="8" name="Shape 5"/>
+            <a:endParaRPr lang="en-US" sz="1200" dirty="0"/>
+          </a:p>
+        </p:txBody>
+      </p:sp>
+      <p:sp>
+        <p:nvSpPr>
+          <p:cNvPr id="24" name="Shape 22"/>
           <p:cNvSpPr/>
           <p:nvPr/>
         </p:nvSpPr>
         <p:spPr>
           <a:xfrm>
-            <a:off x="3246120" y="3195696"/>
-            <a:ext cx="2606040" cy="1559184"/>
+            <a:off x="4114800" y="2423160"/>
+            <a:ext cx="4572000" cy="1051560"/>
           </a:xfrm>
           <a:prstGeom prst="roundRect">
             <a:avLst>
-              <a:gd name="adj" fmla="val 4692"/>
+              <a:gd name="adj" fmla="val 6957"/>
             </a:avLst>
           </a:prstGeom>
           <a:solidFill>
@@ -5911,14 +6505,14 @@
       </p:sp>
       <p:sp>
         <p:nvSpPr>
-          <p:cNvPr id="9" name="Text 6"/>
-          <p:cNvSpPr txBox="1"/>
-          <p:nvPr/>
-        </p:nvSpPr>
-        <p:spPr>
-          <a:xfrm>
-            <a:off x="3429000" y="3305424"/>
-            <a:ext cx="2286000" cy="320040"/>
+          <p:cNvPr id="25" name="Text 23"/>
+          <p:cNvSpPr txBox="1"/>
+          <p:nvPr/>
+        </p:nvSpPr>
+        <p:spPr>
+          <a:xfrm>
+            <a:off x="4297680" y="2514600"/>
+            <a:ext cx="4206240" cy="292608"/>
           </a:xfrm>
           <a:prstGeom prst="rect">
             <a:avLst/>
@@ -5950,14 +6544,14 @@
       </p:sp>
       <p:sp>
         <p:nvSpPr>
-          <p:cNvPr id="10" name="Text 7"/>
-          <p:cNvSpPr txBox="1"/>
-          <p:nvPr/>
-        </p:nvSpPr>
-        <p:spPr>
-          <a:xfrm>
-            <a:off x="3429000" y="3652896"/>
-            <a:ext cx="2286000" cy="1010544"/>
+          <p:cNvPr id="26" name="Text 24"/>
+          <p:cNvSpPr txBox="1"/>
+          <p:nvPr/>
+        </p:nvSpPr>
+        <p:spPr>
+          <a:xfrm>
+            <a:off x="4297680" y="2834640"/>
+            <a:ext cx="4206240" cy="566928"/>
           </a:xfrm>
           <a:prstGeom prst="rect">
             <a:avLst/>
@@ -5973,7 +6567,7 @@
               <a:buNone/>
             </a:pPr>
             <a:r>
-              <a:rPr lang="en-US" sz="1150" dirty="0">
+              <a:rPr lang="en-US" sz="1200" dirty="0">
                 <a:solidFill>
                   <a:srgbClr val="1F2937"/>
                 </a:solidFill>
@@ -5981,26 +6575,26 @@
                 <a:ea typeface="Calibri" pitchFamily="34" charset="-122"/>
                 <a:cs typeface="Calibri" pitchFamily="34" charset="-120"/>
               </a:rPr>
-              <a:t>Core · Application · Infrastructure · Api · Blazor. Las dependencias apuntan al dominio.</a:t>
-            </a:r>
-            <a:endParaRPr lang="en-US" sz="1150" dirty="0"/>
-          </a:p>
-        </p:txBody>
-      </p:sp>
-      <p:sp>
-        <p:nvSpPr>
-          <p:cNvPr id="11" name="Shape 8"/>
+              <a:t>Core · Application · Infrastructure · Api · Blazor. Las dependencias apuntan al dominio; el controlador delega en MediatR.</a:t>
+            </a:r>
+            <a:endParaRPr lang="en-US" sz="1200" dirty="0"/>
+          </a:p>
+        </p:txBody>
+      </p:sp>
+      <p:sp>
+        <p:nvSpPr>
+          <p:cNvPr id="27" name="Shape 25"/>
           <p:cNvSpPr/>
           <p:nvPr/>
         </p:nvSpPr>
         <p:spPr>
           <a:xfrm>
-            <a:off x="6035040" y="3195696"/>
-            <a:ext cx="2606040" cy="1559184"/>
+            <a:off x="4114800" y="3611880"/>
+            <a:ext cx="4572000" cy="1051560"/>
           </a:xfrm>
           <a:prstGeom prst="roundRect">
             <a:avLst>
-              <a:gd name="adj" fmla="val 4692"/>
+              <a:gd name="adj" fmla="val 6957"/>
             </a:avLst>
           </a:prstGeom>
           <a:solidFill>
@@ -6016,14 +6610,14 @@
       </p:sp>
       <p:sp>
         <p:nvSpPr>
-          <p:cNvPr id="12" name="Text 9"/>
-          <p:cNvSpPr txBox="1"/>
-          <p:nvPr/>
-        </p:nvSpPr>
-        <p:spPr>
-          <a:xfrm>
-            <a:off x="6217920" y="3305424"/>
-            <a:ext cx="2286000" cy="320040"/>
+          <p:cNvPr id="28" name="Text 26"/>
+          <p:cNvSpPr txBox="1"/>
+          <p:nvPr/>
+        </p:nvSpPr>
+        <p:spPr>
+          <a:xfrm>
+            <a:off x="4297680" y="3703320"/>
+            <a:ext cx="4206240" cy="292608"/>
           </a:xfrm>
           <a:prstGeom prst="rect">
             <a:avLst/>
@@ -6055,14 +6649,14 @@
       </p:sp>
       <p:sp>
         <p:nvSpPr>
-          <p:cNvPr id="13" name="Text 10"/>
-          <p:cNvSpPr txBox="1"/>
-          <p:nvPr/>
-        </p:nvSpPr>
-        <p:spPr>
-          <a:xfrm>
-            <a:off x="6217920" y="3652896"/>
-            <a:ext cx="2286000" cy="1010544"/>
+          <p:cNvPr id="29" name="Text 27"/>
+          <p:cNvSpPr txBox="1"/>
+          <p:nvPr/>
+        </p:nvSpPr>
+        <p:spPr>
+          <a:xfrm>
+            <a:off x="4297680" y="4023360"/>
+            <a:ext cx="4206240" cy="566928"/>
           </a:xfrm>
           <a:prstGeom prst="rect">
             <a:avLst/>
@@ -6078,7 +6672,7 @@
               <a:buNone/>
             </a:pPr>
             <a:r>
-              <a:rPr lang="en-US" sz="1150" dirty="0">
+              <a:rPr lang="en-US" sz="1200" dirty="0">
                 <a:solidFill>
                   <a:srgbClr val="1F2937"/>
                 </a:solidFill>
@@ -6086,9 +6680,9 @@
                 <a:ea typeface="Calibri" pitchFamily="34" charset="-122"/>
                 <a:cs typeface="Calibri" pitchFamily="34" charset="-120"/>
               </a:rPr>
-              <a:t>Cookie HttpOnly y SameSite=Strict con sesión de servidor; el navegador nunca ve el token.</a:t>
-            </a:r>
-            <a:endParaRPr lang="en-US" sz="1150" dirty="0"/>
+              <a:t>Cookie HttpOnly y SameSite=Strict con sesión de servidor; el navegador nunca ve el token. La API decide con 401/403.</a:t>
+            </a:r>
+            <a:endParaRPr lang="en-US" sz="1200" dirty="0"/>
           </a:p>
         </p:txBody>
       </p:sp>
@@ -6196,70 +6790,49 @@
                 <a:ea typeface="Calibri" pitchFamily="34" charset="-122"/>
                 <a:cs typeface="Calibri" pitchFamily="34" charset="-120"/>
               </a:rPr>
-              <a:t>Paso 4 — ER generado del esquema real (42 tablas), mostrado en dos vistas parciales</a:t>
+              <a:t>Paso 4 — 42 tablas generadas con migraciones; entidades del enunciado → tablas reales</a:t>
             </a:r>
             <a:endParaRPr lang="en-US" sz="1300" dirty="0"/>
           </a:p>
         </p:txBody>
       </p:sp>
-      <p:pic>
-        <p:nvPicPr>
-          <p:cNvPr id="4" name="Image 0" descr="diagramas/modelo-er-maestros-inventario.png">    </p:cNvPr>
-          <p:cNvPicPr>
-            <a:picLocks noChangeAspect="1"/>
-          </p:cNvPicPr>
-          <p:nvPr/>
-        </p:nvPicPr>
-        <p:blipFill>
-          <a:blip r:embed="rId1"/>
-          <a:stretch>
-            <a:fillRect/>
-          </a:stretch>
-        </p:blipFill>
-        <p:spPr>
-          <a:xfrm>
-            <a:off x="457200" y="1280160"/>
-            <a:ext cx="1783080" cy="2869346"/>
-          </a:xfrm>
-          <a:prstGeom prst="rect">
-            <a:avLst/>
-          </a:prstGeom>
-        </p:spPr>
-      </p:pic>
-      <p:pic>
-        <p:nvPicPr>
-          <p:cNvPr id="5" name="Image 1" descr="diagramas/modelo-er-ventas-cxc.png">    </p:cNvPr>
-          <p:cNvPicPr>
-            <a:picLocks noChangeAspect="1"/>
-          </p:cNvPicPr>
-          <p:nvPr/>
-        </p:nvPicPr>
-        <p:blipFill>
-          <a:blip r:embed="rId2"/>
-          <a:stretch>
-            <a:fillRect/>
-          </a:stretch>
-        </p:blipFill>
-        <p:spPr>
-          <a:xfrm>
-            <a:off x="2468880" y="1280160"/>
-            <a:ext cx="1783080" cy="3239865"/>
-          </a:xfrm>
-          <a:prstGeom prst="rect">
-            <a:avLst/>
-          </a:prstGeom>
-        </p:spPr>
-      </p:pic>
-      <p:sp>
-        <p:nvSpPr>
-          <p:cNvPr id="6" name="Text 2"/>
-          <p:cNvSpPr txBox="1"/>
-          <p:nvPr/>
-        </p:nvSpPr>
-        <p:spPr>
-          <a:xfrm>
-            <a:off x="320040" y="4565745"/>
-            <a:ext cx="2057400" cy="274320"/>
+      <p:sp>
+        <p:nvSpPr>
+          <p:cNvPr id="4" name="Shape 2"/>
+          <p:cNvSpPr/>
+          <p:nvPr/>
+        </p:nvSpPr>
+        <p:spPr>
+          <a:xfrm>
+            <a:off x="457200" y="1234440"/>
+            <a:ext cx="2743200" cy="1737360"/>
+          </a:xfrm>
+          <a:prstGeom prst="roundRect">
+            <a:avLst>
+              <a:gd name="adj" fmla="val 4211"/>
+            </a:avLst>
+          </a:prstGeom>
+          <a:solidFill>
+            <a:srgbClr val="E8EEFC"/>
+          </a:solidFill>
+          <a:ln w="12700">
+            <a:solidFill>
+              <a:srgbClr val="E8EEFC"/>
+            </a:solidFill>
+            <a:prstDash val="solid"/>
+          </a:ln>
+        </p:spPr>
+      </p:sp>
+      <p:sp>
+        <p:nvSpPr>
+          <p:cNvPr id="5" name="Text 3"/>
+          <p:cNvSpPr txBox="1"/>
+          <p:nvPr/>
+        </p:nvSpPr>
+        <p:spPr>
+          <a:xfrm>
+            <a:off x="640080" y="1344168"/>
+            <a:ext cx="2377440" cy="292608"/>
           </a:xfrm>
           <a:prstGeom prst="rect">
             <a:avLst/>
@@ -6271,46 +6844,85 @@
           <a:bodyPr wrap="square" lIns="0" tIns="0" rIns="0" bIns="0" rtlCol="0" anchor="ctr"/>
           <a:lstStyle/>
           <a:p>
-            <a:pPr algn="ctr" indent="0" marL="0">
-              <a:buNone/>
-            </a:pPr>
-            <a:r>
-              <a:rPr lang="en-US" sz="1050" i="1" dirty="0">
-                <a:solidFill>
-                  <a:srgbClr val="5B6475"/>
+            <a:pPr indent="0" marL="0">
+              <a:buNone/>
+            </a:pPr>
+            <a:r>
+              <a:rPr lang="en-US" sz="1500" b="1" dirty="0">
+                <a:solidFill>
+                  <a:srgbClr val="14213D"/>
+                </a:solidFill>
+                <a:latin typeface="Cambria" pitchFamily="34" charset="0"/>
+                <a:ea typeface="Cambria" pitchFamily="34" charset="-122"/>
+                <a:cs typeface="Cambria" pitchFamily="34" charset="-120"/>
+              </a:rPr>
+              <a:t>Usuarios y roles</a:t>
+            </a:r>
+            <a:endParaRPr lang="en-US" sz="1500" dirty="0"/>
+          </a:p>
+        </p:txBody>
+      </p:sp>
+      <p:sp>
+        <p:nvSpPr>
+          <p:cNvPr id="6" name="Text 4"/>
+          <p:cNvSpPr txBox="1"/>
+          <p:nvPr/>
+        </p:nvSpPr>
+        <p:spPr>
+          <a:xfrm>
+            <a:off x="640080" y="1655064"/>
+            <a:ext cx="2377440" cy="868680"/>
+          </a:xfrm>
+          <a:prstGeom prst="rect">
+            <a:avLst/>
+          </a:prstGeom>
+          <a:noFill/>
+          <a:ln/>
+        </p:spPr>
+        <p:txBody>
+          <a:bodyPr wrap="square" lIns="0" tIns="0" rIns="0" bIns="0" rtlCol="0" anchor="t"/>
+          <a:lstStyle/>
+          <a:p>
+            <a:pPr indent="0" marL="0">
+              <a:buNone/>
+            </a:pPr>
+            <a:r>
+              <a:rPr lang="en-US" sz="1100" b="1" dirty="0">
+                <a:solidFill>
+                  <a:srgbClr val="2155D9"/>
                 </a:solidFill>
                 <a:latin typeface="Calibri" pitchFamily="34" charset="0"/>
                 <a:ea typeface="Calibri" pitchFamily="34" charset="-122"/>
                 <a:cs typeface="Calibri" pitchFamily="34" charset="-120"/>
               </a:rPr>
-              <a:t>Maestros e inventario</a:t>
-            </a:r>
-            <a:endParaRPr lang="en-US" sz="1050" dirty="0"/>
-          </a:p>
-        </p:txBody>
-      </p:sp>
-      <p:sp>
-        <p:nvSpPr>
-          <p:cNvPr id="7" name="Text 3"/>
-          <p:cNvSpPr txBox="1"/>
-          <p:nvPr/>
-        </p:nvSpPr>
-        <p:spPr>
-          <a:xfrm>
-            <a:off x="2331720" y="4565745"/>
-            <a:ext cx="2057400" cy="274320"/>
-          </a:xfrm>
-          <a:prstGeom prst="rect">
-            <a:avLst/>
-          </a:prstGeom>
-          <a:noFill/>
-          <a:ln/>
-        </p:spPr>
-        <p:txBody>
-          <a:bodyPr wrap="square" lIns="0" tIns="0" rIns="0" bIns="0" rtlCol="0" anchor="ctr"/>
-          <a:lstStyle/>
-          <a:p>
-            <a:pPr algn="ctr" indent="0" marL="0">
+              <a:t>AspNetUsers · AspNetRoles · AspNetUserRoles</a:t>
+            </a:r>
+            <a:endParaRPr lang="en-US" sz="1100" dirty="0"/>
+          </a:p>
+        </p:txBody>
+      </p:sp>
+      <p:sp>
+        <p:nvSpPr>
+          <p:cNvPr id="7" name="Text 5"/>
+          <p:cNvSpPr txBox="1"/>
+          <p:nvPr/>
+        </p:nvSpPr>
+        <p:spPr>
+          <a:xfrm>
+            <a:off x="640080" y="2532888"/>
+            <a:ext cx="2377440" cy="384048"/>
+          </a:xfrm>
+          <a:prstGeom prst="rect">
+            <a:avLst/>
+          </a:prstGeom>
+          <a:noFill/>
+          <a:ln/>
+        </p:spPr>
+        <p:txBody>
+          <a:bodyPr wrap="square" lIns="0" tIns="0" rIns="0" bIns="0" rtlCol="0" anchor="t"/>
+          <a:lstStyle/>
+          <a:p>
+            <a:pPr indent="0" marL="0">
               <a:buNone/>
             </a:pPr>
             <a:r>
@@ -6322,982 +6934,49 @@
                 <a:ea typeface="Calibri" pitchFamily="34" charset="-122"/>
                 <a:cs typeface="Calibri" pitchFamily="34" charset="-120"/>
               </a:rPr>
-              <a:t>Ventas y CxC</a:t>
+              <a:t>Base AxionERP_Identity (ASP.NET Core Identity)</a:t>
             </a:r>
             <a:endParaRPr lang="en-US" sz="1050" dirty="0"/>
           </a:p>
         </p:txBody>
       </p:sp>
-      <p:graphicFrame>
-        <p:nvGraphicFramePr>
-          <p:cNvPr id="7" name="Table 0"/>
-          <p:cNvGraphicFramePr>
-            <a:graphicFrameLocks noGrp="1"/>
-          </p:cNvGraphicFramePr>
-          <p:nvPr>
-            <p:extLst>
-              <p:ext uri="{D42A27DB-BD31-4B8C-83A1-F6EECF244321}">
-                <p14:modId xmlns:p14="http://schemas.microsoft.com/office/powerpoint/2010/main" val="1579011935"/>
-              </p:ext>
-            </p:extLst>
-          </p:nvPr>
-        </p:nvGraphicFramePr>
-        <p:xfrm>
-          <a:off x="4526280" y="1280160"/>
-          <a:ext cx="4160520" cy="914400"/>
-        </p:xfrm>
-        <a:graphic>
-          <a:graphicData uri="http://schemas.openxmlformats.org/drawingml/2006/table">
-            <a:tbl>
-              <a:tblPr/>
-              <a:tblGrid>
-                <a:gridCol w="1463040"/>
-                <a:gridCol w="2697480"/>
-              </a:tblGrid>
-              <a:tr h="384048">
-                <a:tc>
-                  <a:txBody>
-                    <a:bodyPr/>
-                    <a:lstStyle/>
-                    <a:p>
-                      <a:pPr indent="0" marL="0">
-                        <a:buNone/>
-                      </a:pPr>
-                      <a:r>
-                        <a:rPr lang="en-US" sz="1100" b="1" dirty="0">
-                          <a:solidFill>
-                            <a:srgbClr val="FFFFFF"/>
-                          </a:solidFill>
-                          <a:latin typeface="Calibri" pitchFamily="34" charset="0"/>
-                          <a:ea typeface="Calibri" pitchFamily="34" charset="-122"/>
-                          <a:cs typeface="Calibri" pitchFamily="34" charset="-120"/>
-                        </a:rPr>
-                        <a:t>Entidad solicitada</a:t>
-                      </a:r>
-                      <a:endParaRPr lang="en-US" sz="1100" dirty="0">
-                        <a:latin typeface="Calibri" charset="0"/>
-                        <a:ea typeface="Calibri" charset="0"/>
-                        <a:cs typeface="Calibri" charset="0"/>
-                      </a:endParaRPr>
-                    </a:p>
-                  </a:txBody>
-                  <a:tcPr marL="91440" marR="91440" marT="45720" marB="45720" anchor="ctr">
-                    <a:lnL w="9525" cap="flat" cmpd="sng" algn="ctr">
-                      <a:solidFill>
-                        <a:srgbClr val="C7D2EA"/>
-                      </a:solidFill>
-                      <a:prstDash val="solid"/>
-                      <a:round/>
-                      <a:headEnd type="none" w="med" len="med"/>
-                      <a:tailEnd type="none" w="med" len="med"/>
-                    </a:lnL>
-                    <a:lnR w="9525" cap="flat" cmpd="sng" algn="ctr">
-                      <a:solidFill>
-                        <a:srgbClr val="C7D2EA"/>
-                      </a:solidFill>
-                      <a:prstDash val="solid"/>
-                      <a:round/>
-                      <a:headEnd type="none" w="med" len="med"/>
-                      <a:tailEnd type="none" w="med" len="med"/>
-                    </a:lnR>
-                    <a:lnT w="9525" cap="flat" cmpd="sng" algn="ctr">
-                      <a:solidFill>
-                        <a:srgbClr val="C7D2EA"/>
-                      </a:solidFill>
-                      <a:prstDash val="solid"/>
-                      <a:round/>
-                      <a:headEnd type="none" w="med" len="med"/>
-                      <a:tailEnd type="none" w="med" len="med"/>
-                    </a:lnT>
-                    <a:lnB w="9525" cap="flat" cmpd="sng" algn="ctr">
-                      <a:solidFill>
-                        <a:srgbClr val="C7D2EA"/>
-                      </a:solidFill>
-                      <a:prstDash val="solid"/>
-                      <a:round/>
-                      <a:headEnd type="none" w="med" len="med"/>
-                      <a:tailEnd type="none" w="med" len="med"/>
-                    </a:lnB>
-                    <a:solidFill>
-                      <a:srgbClr val="14213D"/>
-                    </a:solidFill>
-                  </a:tcPr>
-                </a:tc>
-                <a:tc>
-                  <a:txBody>
-                    <a:bodyPr/>
-                    <a:lstStyle/>
-                    <a:p>
-                      <a:pPr indent="0" marL="0">
-                        <a:buNone/>
-                      </a:pPr>
-                      <a:r>
-                        <a:rPr lang="en-US" sz="1100" b="1" dirty="0">
-                          <a:solidFill>
-                            <a:srgbClr val="FFFFFF"/>
-                          </a:solidFill>
-                          <a:latin typeface="Calibri" pitchFamily="34" charset="0"/>
-                          <a:ea typeface="Calibri" pitchFamily="34" charset="-122"/>
-                          <a:cs typeface="Calibri" pitchFamily="34" charset="-120"/>
-                        </a:rPr>
-                        <a:t>Tablas reales</a:t>
-                      </a:r>
-                      <a:endParaRPr lang="en-US" sz="1100" dirty="0">
-                        <a:latin typeface="Calibri" charset="0"/>
-                        <a:ea typeface="Calibri" charset="0"/>
-                        <a:cs typeface="Calibri" charset="0"/>
-                      </a:endParaRPr>
-                    </a:p>
-                  </a:txBody>
-                  <a:tcPr marL="91440" marR="91440" marT="45720" marB="45720" anchor="ctr">
-                    <a:lnL w="9525" cap="flat" cmpd="sng" algn="ctr">
-                      <a:solidFill>
-                        <a:srgbClr val="C7D2EA"/>
-                      </a:solidFill>
-                      <a:prstDash val="solid"/>
-                      <a:round/>
-                      <a:headEnd type="none" w="med" len="med"/>
-                      <a:tailEnd type="none" w="med" len="med"/>
-                    </a:lnL>
-                    <a:lnR w="9525" cap="flat" cmpd="sng" algn="ctr">
-                      <a:solidFill>
-                        <a:srgbClr val="C7D2EA"/>
-                      </a:solidFill>
-                      <a:prstDash val="solid"/>
-                      <a:round/>
-                      <a:headEnd type="none" w="med" len="med"/>
-                      <a:tailEnd type="none" w="med" len="med"/>
-                    </a:lnR>
-                    <a:lnT w="9525" cap="flat" cmpd="sng" algn="ctr">
-                      <a:solidFill>
-                        <a:srgbClr val="C7D2EA"/>
-                      </a:solidFill>
-                      <a:prstDash val="solid"/>
-                      <a:round/>
-                      <a:headEnd type="none" w="med" len="med"/>
-                      <a:tailEnd type="none" w="med" len="med"/>
-                    </a:lnT>
-                    <a:lnB w="9525" cap="flat" cmpd="sng" algn="ctr">
-                      <a:solidFill>
-                        <a:srgbClr val="C7D2EA"/>
-                      </a:solidFill>
-                      <a:prstDash val="solid"/>
-                      <a:round/>
-                      <a:headEnd type="none" w="med" len="med"/>
-                      <a:tailEnd type="none" w="med" len="med"/>
-                    </a:lnB>
-                    <a:solidFill>
-                      <a:srgbClr val="14213D"/>
-                    </a:solidFill>
-                  </a:tcPr>
-                </a:tc>
-              </a:tr>
-              <a:tr h="384048">
-                <a:tc>
-                  <a:txBody>
-                    <a:bodyPr/>
-                    <a:lstStyle/>
-                    <a:p>
-                      <a:pPr indent="0" marL="0">
-                        <a:buNone/>
-                      </a:pPr>
-                      <a:r>
-                        <a:rPr lang="en-US" sz="1100" dirty="0">
-                          <a:solidFill>
-                            <a:srgbClr val="1F2937"/>
-                          </a:solidFill>
-                          <a:latin typeface="Calibri" pitchFamily="34" charset="0"/>
-                          <a:ea typeface="Calibri" pitchFamily="34" charset="-122"/>
-                          <a:cs typeface="Calibri" pitchFamily="34" charset="-120"/>
-                        </a:rPr>
-                        <a:t>Usuarios / Roles</a:t>
-                      </a:r>
-                      <a:endParaRPr lang="en-US" sz="1100" dirty="0">
-                        <a:latin typeface="Calibri" charset="0"/>
-                        <a:ea typeface="Calibri" charset="0"/>
-                        <a:cs typeface="Calibri" charset="0"/>
-                      </a:endParaRPr>
-                    </a:p>
-                  </a:txBody>
-                  <a:tcPr marL="91440" marR="91440" marT="45720" marB="45720" anchor="ctr">
-                    <a:lnL w="9525" cap="flat" cmpd="sng" algn="ctr">
-                      <a:solidFill>
-                        <a:srgbClr val="C7D2EA"/>
-                      </a:solidFill>
-                      <a:prstDash val="solid"/>
-                      <a:round/>
-                      <a:headEnd type="none" w="med" len="med"/>
-                      <a:tailEnd type="none" w="med" len="med"/>
-                    </a:lnL>
-                    <a:lnR w="9525" cap="flat" cmpd="sng" algn="ctr">
-                      <a:solidFill>
-                        <a:srgbClr val="C7D2EA"/>
-                      </a:solidFill>
-                      <a:prstDash val="solid"/>
-                      <a:round/>
-                      <a:headEnd type="none" w="med" len="med"/>
-                      <a:tailEnd type="none" w="med" len="med"/>
-                    </a:lnR>
-                    <a:lnT w="9525" cap="flat" cmpd="sng" algn="ctr">
-                      <a:solidFill>
-                        <a:srgbClr val="C7D2EA"/>
-                      </a:solidFill>
-                      <a:prstDash val="solid"/>
-                      <a:round/>
-                      <a:headEnd type="none" w="med" len="med"/>
-                      <a:tailEnd type="none" w="med" len="med"/>
-                    </a:lnT>
-                    <a:lnB w="9525" cap="flat" cmpd="sng" algn="ctr">
-                      <a:solidFill>
-                        <a:srgbClr val="C7D2EA"/>
-                      </a:solidFill>
-                      <a:prstDash val="solid"/>
-                      <a:round/>
-                      <a:headEnd type="none" w="med" len="med"/>
-                      <a:tailEnd type="none" w="med" len="med"/>
-                    </a:lnB>
-                  </a:tcPr>
-                </a:tc>
-                <a:tc>
-                  <a:txBody>
-                    <a:bodyPr/>
-                    <a:lstStyle/>
-                    <a:p>
-                      <a:pPr indent="0" marL="0">
-                        <a:buNone/>
-                      </a:pPr>
-                      <a:r>
-                        <a:rPr lang="en-US" sz="1100" dirty="0">
-                          <a:solidFill>
-                            <a:srgbClr val="1F2937"/>
-                          </a:solidFill>
-                          <a:latin typeface="Calibri" pitchFamily="34" charset="0"/>
-                          <a:ea typeface="Calibri" pitchFamily="34" charset="-122"/>
-                          <a:cs typeface="Calibri" pitchFamily="34" charset="-120"/>
-                        </a:rPr>
-                        <a:t>AspNetUsers, AspNetRoles, AspNetUserRoles</a:t>
-                      </a:r>
-                      <a:endParaRPr lang="en-US" sz="1100" dirty="0">
-                        <a:latin typeface="Calibri" charset="0"/>
-                        <a:ea typeface="Calibri" charset="0"/>
-                        <a:cs typeface="Calibri" charset="0"/>
-                      </a:endParaRPr>
-                    </a:p>
-                  </a:txBody>
-                  <a:tcPr marL="91440" marR="91440" marT="45720" marB="45720" anchor="ctr">
-                    <a:lnL w="9525" cap="flat" cmpd="sng" algn="ctr">
-                      <a:solidFill>
-                        <a:srgbClr val="C7D2EA"/>
-                      </a:solidFill>
-                      <a:prstDash val="solid"/>
-                      <a:round/>
-                      <a:headEnd type="none" w="med" len="med"/>
-                      <a:tailEnd type="none" w="med" len="med"/>
-                    </a:lnL>
-                    <a:lnR w="9525" cap="flat" cmpd="sng" algn="ctr">
-                      <a:solidFill>
-                        <a:srgbClr val="C7D2EA"/>
-                      </a:solidFill>
-                      <a:prstDash val="solid"/>
-                      <a:round/>
-                      <a:headEnd type="none" w="med" len="med"/>
-                      <a:tailEnd type="none" w="med" len="med"/>
-                    </a:lnR>
-                    <a:lnT w="9525" cap="flat" cmpd="sng" algn="ctr">
-                      <a:solidFill>
-                        <a:srgbClr val="C7D2EA"/>
-                      </a:solidFill>
-                      <a:prstDash val="solid"/>
-                      <a:round/>
-                      <a:headEnd type="none" w="med" len="med"/>
-                      <a:tailEnd type="none" w="med" len="med"/>
-                    </a:lnT>
-                    <a:lnB w="9525" cap="flat" cmpd="sng" algn="ctr">
-                      <a:solidFill>
-                        <a:srgbClr val="C7D2EA"/>
-                      </a:solidFill>
-                      <a:prstDash val="solid"/>
-                      <a:round/>
-                      <a:headEnd type="none" w="med" len="med"/>
-                      <a:tailEnd type="none" w="med" len="med"/>
-                    </a:lnB>
-                  </a:tcPr>
-                </a:tc>
-              </a:tr>
-              <a:tr h="384048">
-                <a:tc>
-                  <a:txBody>
-                    <a:bodyPr/>
-                    <a:lstStyle/>
-                    <a:p>
-                      <a:pPr indent="0" marL="0">
-                        <a:buNone/>
-                      </a:pPr>
-                      <a:r>
-                        <a:rPr lang="en-US" sz="1100" dirty="0">
-                          <a:solidFill>
-                            <a:srgbClr val="1F2937"/>
-                          </a:solidFill>
-                          <a:latin typeface="Calibri" pitchFamily="34" charset="0"/>
-                          <a:ea typeface="Calibri" pitchFamily="34" charset="-122"/>
-                          <a:cs typeface="Calibri" pitchFamily="34" charset="-120"/>
-                        </a:rPr>
-                        <a:t>Clientes</a:t>
-                      </a:r>
-                      <a:endParaRPr lang="en-US" sz="1100" dirty="0">
-                        <a:latin typeface="Calibri" charset="0"/>
-                        <a:ea typeface="Calibri" charset="0"/>
-                        <a:cs typeface="Calibri" charset="0"/>
-                      </a:endParaRPr>
-                    </a:p>
-                  </a:txBody>
-                  <a:tcPr marL="91440" marR="91440" marT="45720" marB="45720" anchor="ctr">
-                    <a:lnL w="9525" cap="flat" cmpd="sng" algn="ctr">
-                      <a:solidFill>
-                        <a:srgbClr val="C7D2EA"/>
-                      </a:solidFill>
-                      <a:prstDash val="solid"/>
-                      <a:round/>
-                      <a:headEnd type="none" w="med" len="med"/>
-                      <a:tailEnd type="none" w="med" len="med"/>
-                    </a:lnL>
-                    <a:lnR w="9525" cap="flat" cmpd="sng" algn="ctr">
-                      <a:solidFill>
-                        <a:srgbClr val="C7D2EA"/>
-                      </a:solidFill>
-                      <a:prstDash val="solid"/>
-                      <a:round/>
-                      <a:headEnd type="none" w="med" len="med"/>
-                      <a:tailEnd type="none" w="med" len="med"/>
-                    </a:lnR>
-                    <a:lnT w="9525" cap="flat" cmpd="sng" algn="ctr">
-                      <a:solidFill>
-                        <a:srgbClr val="C7D2EA"/>
-                      </a:solidFill>
-                      <a:prstDash val="solid"/>
-                      <a:round/>
-                      <a:headEnd type="none" w="med" len="med"/>
-                      <a:tailEnd type="none" w="med" len="med"/>
-                    </a:lnT>
-                    <a:lnB w="9525" cap="flat" cmpd="sng" algn="ctr">
-                      <a:solidFill>
-                        <a:srgbClr val="C7D2EA"/>
-                      </a:solidFill>
-                      <a:prstDash val="solid"/>
-                      <a:round/>
-                      <a:headEnd type="none" w="med" len="med"/>
-                      <a:tailEnd type="none" w="med" len="med"/>
-                    </a:lnB>
-                  </a:tcPr>
-                </a:tc>
-                <a:tc>
-                  <a:txBody>
-                    <a:bodyPr/>
-                    <a:lstStyle/>
-                    <a:p>
-                      <a:pPr indent="0" marL="0">
-                        <a:buNone/>
-                      </a:pPr>
-                      <a:r>
-                        <a:rPr lang="en-US" sz="1100" dirty="0">
-                          <a:solidFill>
-                            <a:srgbClr val="1F2937"/>
-                          </a:solidFill>
-                          <a:latin typeface="Calibri" pitchFamily="34" charset="0"/>
-                          <a:ea typeface="Calibri" pitchFamily="34" charset="-122"/>
-                          <a:cs typeface="Calibri" pitchFamily="34" charset="-120"/>
-                        </a:rPr>
-                        <a:t>SociosNegocio</a:t>
-                      </a:r>
-                      <a:endParaRPr lang="en-US" sz="1100" dirty="0">
-                        <a:latin typeface="Calibri" charset="0"/>
-                        <a:ea typeface="Calibri" charset="0"/>
-                        <a:cs typeface="Calibri" charset="0"/>
-                      </a:endParaRPr>
-                    </a:p>
-                  </a:txBody>
-                  <a:tcPr marL="91440" marR="91440" marT="45720" marB="45720" anchor="ctr">
-                    <a:lnL w="9525" cap="flat" cmpd="sng" algn="ctr">
-                      <a:solidFill>
-                        <a:srgbClr val="C7D2EA"/>
-                      </a:solidFill>
-                      <a:prstDash val="solid"/>
-                      <a:round/>
-                      <a:headEnd type="none" w="med" len="med"/>
-                      <a:tailEnd type="none" w="med" len="med"/>
-                    </a:lnL>
-                    <a:lnR w="9525" cap="flat" cmpd="sng" algn="ctr">
-                      <a:solidFill>
-                        <a:srgbClr val="C7D2EA"/>
-                      </a:solidFill>
-                      <a:prstDash val="solid"/>
-                      <a:round/>
-                      <a:headEnd type="none" w="med" len="med"/>
-                      <a:tailEnd type="none" w="med" len="med"/>
-                    </a:lnR>
-                    <a:lnT w="9525" cap="flat" cmpd="sng" algn="ctr">
-                      <a:solidFill>
-                        <a:srgbClr val="C7D2EA"/>
-                      </a:solidFill>
-                      <a:prstDash val="solid"/>
-                      <a:round/>
-                      <a:headEnd type="none" w="med" len="med"/>
-                      <a:tailEnd type="none" w="med" len="med"/>
-                    </a:lnT>
-                    <a:lnB w="9525" cap="flat" cmpd="sng" algn="ctr">
-                      <a:solidFill>
-                        <a:srgbClr val="C7D2EA"/>
-                      </a:solidFill>
-                      <a:prstDash val="solid"/>
-                      <a:round/>
-                      <a:headEnd type="none" w="med" len="med"/>
-                      <a:tailEnd type="none" w="med" len="med"/>
-                    </a:lnB>
-                  </a:tcPr>
-                </a:tc>
-              </a:tr>
-              <a:tr h="384048">
-                <a:tc>
-                  <a:txBody>
-                    <a:bodyPr/>
-                    <a:lstStyle/>
-                    <a:p>
-                      <a:pPr indent="0" marL="0">
-                        <a:buNone/>
-                      </a:pPr>
-                      <a:r>
-                        <a:rPr lang="en-US" sz="1100" dirty="0">
-                          <a:solidFill>
-                            <a:srgbClr val="1F2937"/>
-                          </a:solidFill>
-                          <a:latin typeface="Calibri" pitchFamily="34" charset="0"/>
-                          <a:ea typeface="Calibri" pitchFamily="34" charset="-122"/>
-                          <a:cs typeface="Calibri" pitchFamily="34" charset="-120"/>
-                        </a:rPr>
-                        <a:t>Productos / Categorías</a:t>
-                      </a:r>
-                      <a:endParaRPr lang="en-US" sz="1100" dirty="0">
-                        <a:latin typeface="Calibri" charset="0"/>
-                        <a:ea typeface="Calibri" charset="0"/>
-                        <a:cs typeface="Calibri" charset="0"/>
-                      </a:endParaRPr>
-                    </a:p>
-                  </a:txBody>
-                  <a:tcPr marL="91440" marR="91440" marT="45720" marB="45720" anchor="ctr">
-                    <a:lnL w="9525" cap="flat" cmpd="sng" algn="ctr">
-                      <a:solidFill>
-                        <a:srgbClr val="C7D2EA"/>
-                      </a:solidFill>
-                      <a:prstDash val="solid"/>
-                      <a:round/>
-                      <a:headEnd type="none" w="med" len="med"/>
-                      <a:tailEnd type="none" w="med" len="med"/>
-                    </a:lnL>
-                    <a:lnR w="9525" cap="flat" cmpd="sng" algn="ctr">
-                      <a:solidFill>
-                        <a:srgbClr val="C7D2EA"/>
-                      </a:solidFill>
-                      <a:prstDash val="solid"/>
-                      <a:round/>
-                      <a:headEnd type="none" w="med" len="med"/>
-                      <a:tailEnd type="none" w="med" len="med"/>
-                    </a:lnR>
-                    <a:lnT w="9525" cap="flat" cmpd="sng" algn="ctr">
-                      <a:solidFill>
-                        <a:srgbClr val="C7D2EA"/>
-                      </a:solidFill>
-                      <a:prstDash val="solid"/>
-                      <a:round/>
-                      <a:headEnd type="none" w="med" len="med"/>
-                      <a:tailEnd type="none" w="med" len="med"/>
-                    </a:lnT>
-                    <a:lnB w="9525" cap="flat" cmpd="sng" algn="ctr">
-                      <a:solidFill>
-                        <a:srgbClr val="C7D2EA"/>
-                      </a:solidFill>
-                      <a:prstDash val="solid"/>
-                      <a:round/>
-                      <a:headEnd type="none" w="med" len="med"/>
-                      <a:tailEnd type="none" w="med" len="med"/>
-                    </a:lnB>
-                  </a:tcPr>
-                </a:tc>
-                <a:tc>
-                  <a:txBody>
-                    <a:bodyPr/>
-                    <a:lstStyle/>
-                    <a:p>
-                      <a:pPr indent="0" marL="0">
-                        <a:buNone/>
-                      </a:pPr>
-                      <a:r>
-                        <a:rPr lang="en-US" sz="1100" dirty="0">
-                          <a:solidFill>
-                            <a:srgbClr val="1F2937"/>
-                          </a:solidFill>
-                          <a:latin typeface="Calibri" pitchFamily="34" charset="0"/>
-                          <a:ea typeface="Calibri" pitchFamily="34" charset="-122"/>
-                          <a:cs typeface="Calibri" pitchFamily="34" charset="-120"/>
-                        </a:rPr>
-                        <a:t>Productos, CategoriasProducto</a:t>
-                      </a:r>
-                      <a:endParaRPr lang="en-US" sz="1100" dirty="0">
-                        <a:latin typeface="Calibri" charset="0"/>
-                        <a:ea typeface="Calibri" charset="0"/>
-                        <a:cs typeface="Calibri" charset="0"/>
-                      </a:endParaRPr>
-                    </a:p>
-                  </a:txBody>
-                  <a:tcPr marL="91440" marR="91440" marT="45720" marB="45720" anchor="ctr">
-                    <a:lnL w="9525" cap="flat" cmpd="sng" algn="ctr">
-                      <a:solidFill>
-                        <a:srgbClr val="C7D2EA"/>
-                      </a:solidFill>
-                      <a:prstDash val="solid"/>
-                      <a:round/>
-                      <a:headEnd type="none" w="med" len="med"/>
-                      <a:tailEnd type="none" w="med" len="med"/>
-                    </a:lnL>
-                    <a:lnR w="9525" cap="flat" cmpd="sng" algn="ctr">
-                      <a:solidFill>
-                        <a:srgbClr val="C7D2EA"/>
-                      </a:solidFill>
-                      <a:prstDash val="solid"/>
-                      <a:round/>
-                      <a:headEnd type="none" w="med" len="med"/>
-                      <a:tailEnd type="none" w="med" len="med"/>
-                    </a:lnR>
-                    <a:lnT w="9525" cap="flat" cmpd="sng" algn="ctr">
-                      <a:solidFill>
-                        <a:srgbClr val="C7D2EA"/>
-                      </a:solidFill>
-                      <a:prstDash val="solid"/>
-                      <a:round/>
-                      <a:headEnd type="none" w="med" len="med"/>
-                      <a:tailEnd type="none" w="med" len="med"/>
-                    </a:lnT>
-                    <a:lnB w="9525" cap="flat" cmpd="sng" algn="ctr">
-                      <a:solidFill>
-                        <a:srgbClr val="C7D2EA"/>
-                      </a:solidFill>
-                      <a:prstDash val="solid"/>
-                      <a:round/>
-                      <a:headEnd type="none" w="med" len="med"/>
-                      <a:tailEnd type="none" w="med" len="med"/>
-                    </a:lnB>
-                  </a:tcPr>
-                </a:tc>
-              </a:tr>
-              <a:tr h="384048">
-                <a:tc>
-                  <a:txBody>
-                    <a:bodyPr/>
-                    <a:lstStyle/>
-                    <a:p>
-                      <a:pPr indent="0" marL="0">
-                        <a:buNone/>
-                      </a:pPr>
-                      <a:r>
-                        <a:rPr lang="en-US" sz="1100" dirty="0">
-                          <a:solidFill>
-                            <a:srgbClr val="1F2937"/>
-                          </a:solidFill>
-                          <a:latin typeface="Calibri" pitchFamily="34" charset="0"/>
-                          <a:ea typeface="Calibri" pitchFamily="34" charset="-122"/>
-                          <a:cs typeface="Calibri" pitchFamily="34" charset="-120"/>
-                        </a:rPr>
-                        <a:t>Inventario</a:t>
-                      </a:r>
-                      <a:endParaRPr lang="en-US" sz="1100" dirty="0">
-                        <a:latin typeface="Calibri" charset="0"/>
-                        <a:ea typeface="Calibri" charset="0"/>
-                        <a:cs typeface="Calibri" charset="0"/>
-                      </a:endParaRPr>
-                    </a:p>
-                  </a:txBody>
-                  <a:tcPr marL="91440" marR="91440" marT="45720" marB="45720" anchor="ctr">
-                    <a:lnL w="9525" cap="flat" cmpd="sng" algn="ctr">
-                      <a:solidFill>
-                        <a:srgbClr val="C7D2EA"/>
-                      </a:solidFill>
-                      <a:prstDash val="solid"/>
-                      <a:round/>
-                      <a:headEnd type="none" w="med" len="med"/>
-                      <a:tailEnd type="none" w="med" len="med"/>
-                    </a:lnL>
-                    <a:lnR w="9525" cap="flat" cmpd="sng" algn="ctr">
-                      <a:solidFill>
-                        <a:srgbClr val="C7D2EA"/>
-                      </a:solidFill>
-                      <a:prstDash val="solid"/>
-                      <a:round/>
-                      <a:headEnd type="none" w="med" len="med"/>
-                      <a:tailEnd type="none" w="med" len="med"/>
-                    </a:lnR>
-                    <a:lnT w="9525" cap="flat" cmpd="sng" algn="ctr">
-                      <a:solidFill>
-                        <a:srgbClr val="C7D2EA"/>
-                      </a:solidFill>
-                      <a:prstDash val="solid"/>
-                      <a:round/>
-                      <a:headEnd type="none" w="med" len="med"/>
-                      <a:tailEnd type="none" w="med" len="med"/>
-                    </a:lnT>
-                    <a:lnB w="9525" cap="flat" cmpd="sng" algn="ctr">
-                      <a:solidFill>
-                        <a:srgbClr val="C7D2EA"/>
-                      </a:solidFill>
-                      <a:prstDash val="solid"/>
-                      <a:round/>
-                      <a:headEnd type="none" w="med" len="med"/>
-                      <a:tailEnd type="none" w="med" len="med"/>
-                    </a:lnB>
-                  </a:tcPr>
-                </a:tc>
-                <a:tc>
-                  <a:txBody>
-                    <a:bodyPr/>
-                    <a:lstStyle/>
-                    <a:p>
-                      <a:pPr indent="0" marL="0">
-                        <a:buNone/>
-                      </a:pPr>
-                      <a:r>
-                        <a:rPr lang="en-US" sz="1100" dirty="0">
-                          <a:solidFill>
-                            <a:srgbClr val="1F2937"/>
-                          </a:solidFill>
-                          <a:latin typeface="Calibri" pitchFamily="34" charset="0"/>
-                          <a:ea typeface="Calibri" pitchFamily="34" charset="-122"/>
-                          <a:cs typeface="Calibri" pitchFamily="34" charset="-120"/>
-                        </a:rPr>
-                        <a:t>MovimientosProducto, MovimientosValor, Almacenes</a:t>
-                      </a:r>
-                      <a:endParaRPr lang="en-US" sz="1100" dirty="0">
-                        <a:latin typeface="Calibri" charset="0"/>
-                        <a:ea typeface="Calibri" charset="0"/>
-                        <a:cs typeface="Calibri" charset="0"/>
-                      </a:endParaRPr>
-                    </a:p>
-                  </a:txBody>
-                  <a:tcPr marL="91440" marR="91440" marT="45720" marB="45720" anchor="ctr">
-                    <a:lnL w="9525" cap="flat" cmpd="sng" algn="ctr">
-                      <a:solidFill>
-                        <a:srgbClr val="C7D2EA"/>
-                      </a:solidFill>
-                      <a:prstDash val="solid"/>
-                      <a:round/>
-                      <a:headEnd type="none" w="med" len="med"/>
-                      <a:tailEnd type="none" w="med" len="med"/>
-                    </a:lnL>
-                    <a:lnR w="9525" cap="flat" cmpd="sng" algn="ctr">
-                      <a:solidFill>
-                        <a:srgbClr val="C7D2EA"/>
-                      </a:solidFill>
-                      <a:prstDash val="solid"/>
-                      <a:round/>
-                      <a:headEnd type="none" w="med" len="med"/>
-                      <a:tailEnd type="none" w="med" len="med"/>
-                    </a:lnR>
-                    <a:lnT w="9525" cap="flat" cmpd="sng" algn="ctr">
-                      <a:solidFill>
-                        <a:srgbClr val="C7D2EA"/>
-                      </a:solidFill>
-                      <a:prstDash val="solid"/>
-                      <a:round/>
-                      <a:headEnd type="none" w="med" len="med"/>
-                      <a:tailEnd type="none" w="med" len="med"/>
-                    </a:lnT>
-                    <a:lnB w="9525" cap="flat" cmpd="sng" algn="ctr">
-                      <a:solidFill>
-                        <a:srgbClr val="C7D2EA"/>
-                      </a:solidFill>
-                      <a:prstDash val="solid"/>
-                      <a:round/>
-                      <a:headEnd type="none" w="med" len="med"/>
-                      <a:tailEnd type="none" w="med" len="med"/>
-                    </a:lnB>
-                  </a:tcPr>
-                </a:tc>
-              </a:tr>
-              <a:tr h="384048">
-                <a:tc>
-                  <a:txBody>
-                    <a:bodyPr/>
-                    <a:lstStyle/>
-                    <a:p>
-                      <a:pPr indent="0" marL="0">
-                        <a:buNone/>
-                      </a:pPr>
-                      <a:r>
-                        <a:rPr lang="en-US" sz="1100" dirty="0">
-                          <a:solidFill>
-                            <a:srgbClr val="1F2937"/>
-                          </a:solidFill>
-                          <a:latin typeface="Calibri" pitchFamily="34" charset="0"/>
-                          <a:ea typeface="Calibri" pitchFamily="34" charset="-122"/>
-                          <a:cs typeface="Calibri" pitchFamily="34" charset="-120"/>
-                        </a:rPr>
-                        <a:t>Ventas / Facturas</a:t>
-                      </a:r>
-                      <a:endParaRPr lang="en-US" sz="1100" dirty="0">
-                        <a:latin typeface="Calibri" charset="0"/>
-                        <a:ea typeface="Calibri" charset="0"/>
-                        <a:cs typeface="Calibri" charset="0"/>
-                      </a:endParaRPr>
-                    </a:p>
-                  </a:txBody>
-                  <a:tcPr marL="91440" marR="91440" marT="45720" marB="45720" anchor="ctr">
-                    <a:lnL w="9525" cap="flat" cmpd="sng" algn="ctr">
-                      <a:solidFill>
-                        <a:srgbClr val="C7D2EA"/>
-                      </a:solidFill>
-                      <a:prstDash val="solid"/>
-                      <a:round/>
-                      <a:headEnd type="none" w="med" len="med"/>
-                      <a:tailEnd type="none" w="med" len="med"/>
-                    </a:lnL>
-                    <a:lnR w="9525" cap="flat" cmpd="sng" algn="ctr">
-                      <a:solidFill>
-                        <a:srgbClr val="C7D2EA"/>
-                      </a:solidFill>
-                      <a:prstDash val="solid"/>
-                      <a:round/>
-                      <a:headEnd type="none" w="med" len="med"/>
-                      <a:tailEnd type="none" w="med" len="med"/>
-                    </a:lnR>
-                    <a:lnT w="9525" cap="flat" cmpd="sng" algn="ctr">
-                      <a:solidFill>
-                        <a:srgbClr val="C7D2EA"/>
-                      </a:solidFill>
-                      <a:prstDash val="solid"/>
-                      <a:round/>
-                      <a:headEnd type="none" w="med" len="med"/>
-                      <a:tailEnd type="none" w="med" len="med"/>
-                    </a:lnT>
-                    <a:lnB w="9525" cap="flat" cmpd="sng" algn="ctr">
-                      <a:solidFill>
-                        <a:srgbClr val="C7D2EA"/>
-                      </a:solidFill>
-                      <a:prstDash val="solid"/>
-                      <a:round/>
-                      <a:headEnd type="none" w="med" len="med"/>
-                      <a:tailEnd type="none" w="med" len="med"/>
-                    </a:lnB>
-                  </a:tcPr>
-                </a:tc>
-                <a:tc>
-                  <a:txBody>
-                    <a:bodyPr/>
-                    <a:lstStyle/>
-                    <a:p>
-                      <a:pPr indent="0" marL="0">
-                        <a:buNone/>
-                      </a:pPr>
-                      <a:r>
-                        <a:rPr lang="en-US" sz="1100" dirty="0">
-                          <a:solidFill>
-                            <a:srgbClr val="1F2937"/>
-                          </a:solidFill>
-                          <a:latin typeface="Calibri" pitchFamily="34" charset="0"/>
-                          <a:ea typeface="Calibri" pitchFamily="34" charset="-122"/>
-                          <a:cs typeface="Calibri" pitchFamily="34" charset="-120"/>
-                        </a:rPr>
-                        <a:t>FacturasVenta, LineasFacturaVenta (+ borradores)</a:t>
-                      </a:r>
-                      <a:endParaRPr lang="en-US" sz="1100" dirty="0">
-                        <a:latin typeface="Calibri" charset="0"/>
-                        <a:ea typeface="Calibri" charset="0"/>
-                        <a:cs typeface="Calibri" charset="0"/>
-                      </a:endParaRPr>
-                    </a:p>
-                  </a:txBody>
-                  <a:tcPr marL="91440" marR="91440" marT="45720" marB="45720" anchor="ctr">
-                    <a:lnL w="9525" cap="flat" cmpd="sng" algn="ctr">
-                      <a:solidFill>
-                        <a:srgbClr val="C7D2EA"/>
-                      </a:solidFill>
-                      <a:prstDash val="solid"/>
-                      <a:round/>
-                      <a:headEnd type="none" w="med" len="med"/>
-                      <a:tailEnd type="none" w="med" len="med"/>
-                    </a:lnL>
-                    <a:lnR w="9525" cap="flat" cmpd="sng" algn="ctr">
-                      <a:solidFill>
-                        <a:srgbClr val="C7D2EA"/>
-                      </a:solidFill>
-                      <a:prstDash val="solid"/>
-                      <a:round/>
-                      <a:headEnd type="none" w="med" len="med"/>
-                      <a:tailEnd type="none" w="med" len="med"/>
-                    </a:lnR>
-                    <a:lnT w="9525" cap="flat" cmpd="sng" algn="ctr">
-                      <a:solidFill>
-                        <a:srgbClr val="C7D2EA"/>
-                      </a:solidFill>
-                      <a:prstDash val="solid"/>
-                      <a:round/>
-                      <a:headEnd type="none" w="med" len="med"/>
-                      <a:tailEnd type="none" w="med" len="med"/>
-                    </a:lnT>
-                    <a:lnB w="9525" cap="flat" cmpd="sng" algn="ctr">
-                      <a:solidFill>
-                        <a:srgbClr val="C7D2EA"/>
-                      </a:solidFill>
-                      <a:prstDash val="solid"/>
-                      <a:round/>
-                      <a:headEnd type="none" w="med" len="med"/>
-                      <a:tailEnd type="none" w="med" len="med"/>
-                    </a:lnB>
-                  </a:tcPr>
-                </a:tc>
-              </a:tr>
-              <a:tr h="384048">
-                <a:tc>
-                  <a:txBody>
-                    <a:bodyPr/>
-                    <a:lstStyle/>
-                    <a:p>
-                      <a:pPr indent="0" marL="0">
-                        <a:buNone/>
-                      </a:pPr>
-                      <a:r>
-                        <a:rPr lang="en-US" sz="1100" dirty="0">
-                          <a:solidFill>
-                            <a:srgbClr val="1F2937"/>
-                          </a:solidFill>
-                          <a:latin typeface="Calibri" pitchFamily="34" charset="0"/>
-                          <a:ea typeface="Calibri" pitchFamily="34" charset="-122"/>
-                          <a:cs typeface="Calibri" pitchFamily="34" charset="-120"/>
-                        </a:rPr>
-                        <a:t>Cuentas por cobrar</a:t>
-                      </a:r>
-                      <a:endParaRPr lang="en-US" sz="1100" dirty="0">
-                        <a:latin typeface="Calibri" charset="0"/>
-                        <a:ea typeface="Calibri" charset="0"/>
-                        <a:cs typeface="Calibri" charset="0"/>
-                      </a:endParaRPr>
-                    </a:p>
-                  </a:txBody>
-                  <a:tcPr marL="91440" marR="91440" marT="45720" marB="45720" anchor="ctr">
-                    <a:lnL w="9525" cap="flat" cmpd="sng" algn="ctr">
-                      <a:solidFill>
-                        <a:srgbClr val="C7D2EA"/>
-                      </a:solidFill>
-                      <a:prstDash val="solid"/>
-                      <a:round/>
-                      <a:headEnd type="none" w="med" len="med"/>
-                      <a:tailEnd type="none" w="med" len="med"/>
-                    </a:lnL>
-                    <a:lnR w="9525" cap="flat" cmpd="sng" algn="ctr">
-                      <a:solidFill>
-                        <a:srgbClr val="C7D2EA"/>
-                      </a:solidFill>
-                      <a:prstDash val="solid"/>
-                      <a:round/>
-                      <a:headEnd type="none" w="med" len="med"/>
-                      <a:tailEnd type="none" w="med" len="med"/>
-                    </a:lnR>
-                    <a:lnT w="9525" cap="flat" cmpd="sng" algn="ctr">
-                      <a:solidFill>
-                        <a:srgbClr val="C7D2EA"/>
-                      </a:solidFill>
-                      <a:prstDash val="solid"/>
-                      <a:round/>
-                      <a:headEnd type="none" w="med" len="med"/>
-                      <a:tailEnd type="none" w="med" len="med"/>
-                    </a:lnT>
-                    <a:lnB w="9525" cap="flat" cmpd="sng" algn="ctr">
-                      <a:solidFill>
-                        <a:srgbClr val="C7D2EA"/>
-                      </a:solidFill>
-                      <a:prstDash val="solid"/>
-                      <a:round/>
-                      <a:headEnd type="none" w="med" len="med"/>
-                      <a:tailEnd type="none" w="med" len="med"/>
-                    </a:lnB>
-                  </a:tcPr>
-                </a:tc>
-                <a:tc>
-                  <a:txBody>
-                    <a:bodyPr/>
-                    <a:lstStyle/>
-                    <a:p>
-                      <a:pPr indent="0" marL="0">
-                        <a:buNone/>
-                      </a:pPr>
-                      <a:r>
-                        <a:rPr lang="en-US" sz="1100" dirty="0">
-                          <a:solidFill>
-                            <a:srgbClr val="1F2937"/>
-                          </a:solidFill>
-                          <a:latin typeface="Calibri" pitchFamily="34" charset="0"/>
-                          <a:ea typeface="Calibri" pitchFamily="34" charset="-122"/>
-                          <a:cs typeface="Calibri" pitchFamily="34" charset="-120"/>
-                        </a:rPr>
-                        <a:t>MovimientosCliente, MovimientosClienteDetalle</a:t>
-                      </a:r>
-                      <a:endParaRPr lang="en-US" sz="1100" dirty="0">
-                        <a:latin typeface="Calibri" charset="0"/>
-                        <a:ea typeface="Calibri" charset="0"/>
-                        <a:cs typeface="Calibri" charset="0"/>
-                      </a:endParaRPr>
-                    </a:p>
-                  </a:txBody>
-                  <a:tcPr marL="91440" marR="91440" marT="45720" marB="45720" anchor="ctr">
-                    <a:lnL w="9525" cap="flat" cmpd="sng" algn="ctr">
-                      <a:solidFill>
-                        <a:srgbClr val="C7D2EA"/>
-                      </a:solidFill>
-                      <a:prstDash val="solid"/>
-                      <a:round/>
-                      <a:headEnd type="none" w="med" len="med"/>
-                      <a:tailEnd type="none" w="med" len="med"/>
-                    </a:lnL>
-                    <a:lnR w="9525" cap="flat" cmpd="sng" algn="ctr">
-                      <a:solidFill>
-                        <a:srgbClr val="C7D2EA"/>
-                      </a:solidFill>
-                      <a:prstDash val="solid"/>
-                      <a:round/>
-                      <a:headEnd type="none" w="med" len="med"/>
-                      <a:tailEnd type="none" w="med" len="med"/>
-                    </a:lnR>
-                    <a:lnT w="9525" cap="flat" cmpd="sng" algn="ctr">
-                      <a:solidFill>
-                        <a:srgbClr val="C7D2EA"/>
-                      </a:solidFill>
-                      <a:prstDash val="solid"/>
-                      <a:round/>
-                      <a:headEnd type="none" w="med" len="med"/>
-                      <a:tailEnd type="none" w="med" len="med"/>
-                    </a:lnT>
-                    <a:lnB w="9525" cap="flat" cmpd="sng" algn="ctr">
-                      <a:solidFill>
-                        <a:srgbClr val="C7D2EA"/>
-                      </a:solidFill>
-                      <a:prstDash val="solid"/>
-                      <a:round/>
-                      <a:headEnd type="none" w="med" len="med"/>
-                      <a:tailEnd type="none" w="med" len="med"/>
-                    </a:lnB>
-                  </a:tcPr>
-                </a:tc>
-              </a:tr>
-            </a:tbl>
-          </a:graphicData>
-        </a:graphic>
-      </p:graphicFrame>
-      <p:sp>
-        <p:nvSpPr>
-          <p:cNvPr id="9" name="Text 4"/>
-          <p:cNvSpPr txBox="1"/>
-          <p:nvPr/>
-        </p:nvSpPr>
-        <p:spPr>
-          <a:xfrm>
-            <a:off x="4526280" y="4160520"/>
-            <a:ext cx="4160520" cy="502920"/>
+      <p:sp>
+        <p:nvSpPr>
+          <p:cNvPr id="8" name="Shape 6"/>
+          <p:cNvSpPr/>
+          <p:nvPr/>
+        </p:nvSpPr>
+        <p:spPr>
+          <a:xfrm>
+            <a:off x="3383280" y="1234440"/>
+            <a:ext cx="2743200" cy="1737360"/>
+          </a:xfrm>
+          <a:prstGeom prst="roundRect">
+            <a:avLst>
+              <a:gd name="adj" fmla="val 4211"/>
+            </a:avLst>
+          </a:prstGeom>
+          <a:solidFill>
+            <a:srgbClr val="E8EEFC"/>
+          </a:solidFill>
+          <a:ln w="12700">
+            <a:solidFill>
+              <a:srgbClr val="E8EEFC"/>
+            </a:solidFill>
+            <a:prstDash val="solid"/>
+          </a:ln>
+        </p:spPr>
+      </p:sp>
+      <p:sp>
+        <p:nvSpPr>
+          <p:cNvPr id="9" name="Text 7"/>
+          <p:cNvSpPr txBox="1"/>
+          <p:nvPr/>
+        </p:nvSpPr>
+        <p:spPr>
+          <a:xfrm>
+            <a:off x="3566160" y="1344168"/>
+            <a:ext cx="2377440" cy="292608"/>
           </a:xfrm>
           <a:prstGeom prst="rect">
             <a:avLst/>
@@ -7313,17 +6992,951 @@
               <a:buNone/>
             </a:pPr>
             <a:r>
-              <a:rPr lang="en-US" sz="1100" i="1" dirty="0">
-                <a:solidFill>
-                  <a:srgbClr val="5B6475"/>
+              <a:rPr lang="en-US" sz="1500" b="1" dirty="0">
+                <a:solidFill>
+                  <a:srgbClr val="14213D"/>
+                </a:solidFill>
+                <a:latin typeface="Cambria" pitchFamily="34" charset="0"/>
+                <a:ea typeface="Cambria" pitchFamily="34" charset="-122"/>
+                <a:cs typeface="Cambria" pitchFamily="34" charset="-120"/>
+              </a:rPr>
+              <a:t>Clientes y CxC</a:t>
+            </a:r>
+            <a:endParaRPr lang="en-US" sz="1500" dirty="0"/>
+          </a:p>
+        </p:txBody>
+      </p:sp>
+      <p:sp>
+        <p:nvSpPr>
+          <p:cNvPr id="10" name="Text 8"/>
+          <p:cNvSpPr txBox="1"/>
+          <p:nvPr/>
+        </p:nvSpPr>
+        <p:spPr>
+          <a:xfrm>
+            <a:off x="3566160" y="1655064"/>
+            <a:ext cx="2377440" cy="868680"/>
+          </a:xfrm>
+          <a:prstGeom prst="rect">
+            <a:avLst/>
+          </a:prstGeom>
+          <a:noFill/>
+          <a:ln/>
+        </p:spPr>
+        <p:txBody>
+          <a:bodyPr wrap="square" lIns="0" tIns="0" rIns="0" bIns="0" rtlCol="0" anchor="t"/>
+          <a:lstStyle/>
+          <a:p>
+            <a:pPr indent="0" marL="0">
+              <a:buNone/>
+            </a:pPr>
+            <a:r>
+              <a:rPr lang="en-US" sz="1100" b="1" dirty="0">
+                <a:solidFill>
+                  <a:srgbClr val="2155D9"/>
                 </a:solidFill>
                 <a:latin typeface="Calibri" pitchFamily="34" charset="0"/>
                 <a:ea typeface="Calibri" pitchFamily="34" charset="-122"/>
                 <a:cs typeface="Calibri" pitchFamily="34" charset="-120"/>
               </a:rPr>
-              <a:t>Claves uuid en maestros, número de documento en posteados y bigint en libros; importes numeric(18,4).</a:t>
+              <a:t>SociosNegocio · MovimientosCliente · MovimientosClienteDetalle</a:t>
             </a:r>
             <a:endParaRPr lang="en-US" sz="1100" dirty="0"/>
+          </a:p>
+        </p:txBody>
+      </p:sp>
+      <p:sp>
+        <p:nvSpPr>
+          <p:cNvPr id="11" name="Text 9"/>
+          <p:cNvSpPr txBox="1"/>
+          <p:nvPr/>
+        </p:nvSpPr>
+        <p:spPr>
+          <a:xfrm>
+            <a:off x="3566160" y="2532888"/>
+            <a:ext cx="2377440" cy="384048"/>
+          </a:xfrm>
+          <a:prstGeom prst="rect">
+            <a:avLst/>
+          </a:prstGeom>
+          <a:noFill/>
+          <a:ln/>
+        </p:spPr>
+        <p:txBody>
+          <a:bodyPr wrap="square" lIns="0" tIns="0" rIns="0" bIns="0" rtlCol="0" anchor="t"/>
+          <a:lstStyle/>
+          <a:p>
+            <a:pPr indent="0" marL="0">
+              <a:buNone/>
+            </a:pPr>
+            <a:r>
+              <a:rPr lang="en-US" sz="1050" i="1" dirty="0">
+                <a:solidFill>
+                  <a:srgbClr val="5B6475"/>
+                </a:solidFill>
+                <a:latin typeface="Calibri" pitchFamily="34" charset="0"/>
+                <a:ea typeface="Calibri" pitchFamily="34" charset="-122"/>
+                <a:cs typeface="Calibri" pitchFamily="34" charset="-120"/>
+              </a:rPr>
+              <a:t>Saldo derivado de cargos, cobros y aplicaciones</a:t>
+            </a:r>
+            <a:endParaRPr lang="en-US" sz="1050" dirty="0"/>
+          </a:p>
+        </p:txBody>
+      </p:sp>
+      <p:sp>
+        <p:nvSpPr>
+          <p:cNvPr id="12" name="Shape 10"/>
+          <p:cNvSpPr/>
+          <p:nvPr/>
+        </p:nvSpPr>
+        <p:spPr>
+          <a:xfrm>
+            <a:off x="457200" y="3063240"/>
+            <a:ext cx="2743200" cy="1737360"/>
+          </a:xfrm>
+          <a:prstGeom prst="roundRect">
+            <a:avLst>
+              <a:gd name="adj" fmla="val 4211"/>
+            </a:avLst>
+          </a:prstGeom>
+          <a:solidFill>
+            <a:srgbClr val="E8EEFC"/>
+          </a:solidFill>
+          <a:ln w="12700">
+            <a:solidFill>
+              <a:srgbClr val="E8EEFC"/>
+            </a:solidFill>
+            <a:prstDash val="solid"/>
+          </a:ln>
+        </p:spPr>
+      </p:sp>
+      <p:sp>
+        <p:nvSpPr>
+          <p:cNvPr id="13" name="Text 11"/>
+          <p:cNvSpPr txBox="1"/>
+          <p:nvPr/>
+        </p:nvSpPr>
+        <p:spPr>
+          <a:xfrm>
+            <a:off x="640080" y="3172968"/>
+            <a:ext cx="2377440" cy="292608"/>
+          </a:xfrm>
+          <a:prstGeom prst="rect">
+            <a:avLst/>
+          </a:prstGeom>
+          <a:noFill/>
+          <a:ln/>
+        </p:spPr>
+        <p:txBody>
+          <a:bodyPr wrap="square" lIns="0" tIns="0" rIns="0" bIns="0" rtlCol="0" anchor="ctr"/>
+          <a:lstStyle/>
+          <a:p>
+            <a:pPr indent="0" marL="0">
+              <a:buNone/>
+            </a:pPr>
+            <a:r>
+              <a:rPr lang="en-US" sz="1500" b="1" dirty="0">
+                <a:solidFill>
+                  <a:srgbClr val="14213D"/>
+                </a:solidFill>
+                <a:latin typeface="Cambria" pitchFamily="34" charset="0"/>
+                <a:ea typeface="Cambria" pitchFamily="34" charset="-122"/>
+                <a:cs typeface="Cambria" pitchFamily="34" charset="-120"/>
+              </a:rPr>
+              <a:t>Productos e inventario</a:t>
+            </a:r>
+            <a:endParaRPr lang="en-US" sz="1500" dirty="0"/>
+          </a:p>
+        </p:txBody>
+      </p:sp>
+      <p:sp>
+        <p:nvSpPr>
+          <p:cNvPr id="14" name="Text 12"/>
+          <p:cNvSpPr txBox="1"/>
+          <p:nvPr/>
+        </p:nvSpPr>
+        <p:spPr>
+          <a:xfrm>
+            <a:off x="640080" y="3483864"/>
+            <a:ext cx="2377440" cy="868680"/>
+          </a:xfrm>
+          <a:prstGeom prst="rect">
+            <a:avLst/>
+          </a:prstGeom>
+          <a:noFill/>
+          <a:ln/>
+        </p:spPr>
+        <p:txBody>
+          <a:bodyPr wrap="square" lIns="0" tIns="0" rIns="0" bIns="0" rtlCol="0" anchor="t"/>
+          <a:lstStyle/>
+          <a:p>
+            <a:pPr indent="0" marL="0">
+              <a:buNone/>
+            </a:pPr>
+            <a:r>
+              <a:rPr lang="en-US" sz="1100" b="1" dirty="0">
+                <a:solidFill>
+                  <a:srgbClr val="2155D9"/>
+                </a:solidFill>
+                <a:latin typeface="Calibri" pitchFamily="34" charset="0"/>
+                <a:ea typeface="Calibri" pitchFamily="34" charset="-122"/>
+                <a:cs typeface="Calibri" pitchFamily="34" charset="-120"/>
+              </a:rPr>
+              <a:t>Productos · CategoriasProducto · Almacenes · MovimientosProducto · MovimientosValor</a:t>
+            </a:r>
+            <a:endParaRPr lang="en-US" sz="1100" dirty="0"/>
+          </a:p>
+        </p:txBody>
+      </p:sp>
+      <p:sp>
+        <p:nvSpPr>
+          <p:cNvPr id="15" name="Text 13"/>
+          <p:cNvSpPr txBox="1"/>
+          <p:nvPr/>
+        </p:nvSpPr>
+        <p:spPr>
+          <a:xfrm>
+            <a:off x="640080" y="4361688"/>
+            <a:ext cx="2377440" cy="384048"/>
+          </a:xfrm>
+          <a:prstGeom prst="rect">
+            <a:avLst/>
+          </a:prstGeom>
+          <a:noFill/>
+          <a:ln/>
+        </p:spPr>
+        <p:txBody>
+          <a:bodyPr wrap="square" lIns="0" tIns="0" rIns="0" bIns="0" rtlCol="0" anchor="t"/>
+          <a:lstStyle/>
+          <a:p>
+            <a:pPr indent="0" marL="0">
+              <a:buNone/>
+            </a:pPr>
+            <a:r>
+              <a:rPr lang="en-US" sz="1050" i="1" dirty="0">
+                <a:solidFill>
+                  <a:srgbClr val="5B6475"/>
+                </a:solidFill>
+                <a:latin typeface="Calibri" pitchFamily="34" charset="0"/>
+                <a:ea typeface="Calibri" pitchFamily="34" charset="-122"/>
+                <a:cs typeface="Calibri" pitchFamily="34" charset="-120"/>
+              </a:rPr>
+              <a:t>Existencia y costo derivados de libros append-only</a:t>
+            </a:r>
+            <a:endParaRPr lang="en-US" sz="1050" dirty="0"/>
+          </a:p>
+        </p:txBody>
+      </p:sp>
+      <p:sp>
+        <p:nvSpPr>
+          <p:cNvPr id="16" name="Shape 14"/>
+          <p:cNvSpPr/>
+          <p:nvPr/>
+        </p:nvSpPr>
+        <p:spPr>
+          <a:xfrm>
+            <a:off x="3383280" y="3063240"/>
+            <a:ext cx="2743200" cy="1737360"/>
+          </a:xfrm>
+          <a:prstGeom prst="roundRect">
+            <a:avLst>
+              <a:gd name="adj" fmla="val 4211"/>
+            </a:avLst>
+          </a:prstGeom>
+          <a:solidFill>
+            <a:srgbClr val="E8EEFC"/>
+          </a:solidFill>
+          <a:ln w="12700">
+            <a:solidFill>
+              <a:srgbClr val="E8EEFC"/>
+            </a:solidFill>
+            <a:prstDash val="solid"/>
+          </a:ln>
+        </p:spPr>
+      </p:sp>
+      <p:sp>
+        <p:nvSpPr>
+          <p:cNvPr id="17" name="Text 15"/>
+          <p:cNvSpPr txBox="1"/>
+          <p:nvPr/>
+        </p:nvSpPr>
+        <p:spPr>
+          <a:xfrm>
+            <a:off x="3566160" y="3172968"/>
+            <a:ext cx="2377440" cy="292608"/>
+          </a:xfrm>
+          <a:prstGeom prst="rect">
+            <a:avLst/>
+          </a:prstGeom>
+          <a:noFill/>
+          <a:ln/>
+        </p:spPr>
+        <p:txBody>
+          <a:bodyPr wrap="square" lIns="0" tIns="0" rIns="0" bIns="0" rtlCol="0" anchor="ctr"/>
+          <a:lstStyle/>
+          <a:p>
+            <a:pPr indent="0" marL="0">
+              <a:buNone/>
+            </a:pPr>
+            <a:r>
+              <a:rPr lang="en-US" sz="1500" b="1" dirty="0">
+                <a:solidFill>
+                  <a:srgbClr val="14213D"/>
+                </a:solidFill>
+                <a:latin typeface="Cambria" pitchFamily="34" charset="0"/>
+                <a:ea typeface="Cambria" pitchFamily="34" charset="-122"/>
+                <a:cs typeface="Cambria" pitchFamily="34" charset="-120"/>
+              </a:rPr>
+              <a:t>Ventas y facturas</a:t>
+            </a:r>
+            <a:endParaRPr lang="en-US" sz="1500" dirty="0"/>
+          </a:p>
+        </p:txBody>
+      </p:sp>
+      <p:sp>
+        <p:nvSpPr>
+          <p:cNvPr id="18" name="Text 16"/>
+          <p:cNvSpPr txBox="1"/>
+          <p:nvPr/>
+        </p:nvSpPr>
+        <p:spPr>
+          <a:xfrm>
+            <a:off x="3566160" y="3483864"/>
+            <a:ext cx="2377440" cy="868680"/>
+          </a:xfrm>
+          <a:prstGeom prst="rect">
+            <a:avLst/>
+          </a:prstGeom>
+          <a:noFill/>
+          <a:ln/>
+        </p:spPr>
+        <p:txBody>
+          <a:bodyPr wrap="square" lIns="0" tIns="0" rIns="0" bIns="0" rtlCol="0" anchor="t"/>
+          <a:lstStyle/>
+          <a:p>
+            <a:pPr indent="0" marL="0">
+              <a:buNone/>
+            </a:pPr>
+            <a:r>
+              <a:rPr lang="en-US" sz="1100" b="1" dirty="0">
+                <a:solidFill>
+                  <a:srgbClr val="2155D9"/>
+                </a:solidFill>
+                <a:latin typeface="Calibri" pitchFamily="34" charset="0"/>
+                <a:ea typeface="Calibri" pitchFamily="34" charset="-122"/>
+                <a:cs typeface="Calibri" pitchFamily="34" charset="-120"/>
+              </a:rPr>
+              <a:t>FacturasVentaBorrador → FacturasVenta · LineasFacturaVenta · LineasIvaFacturaVenta</a:t>
+            </a:r>
+            <a:endParaRPr lang="en-US" sz="1100" dirty="0"/>
+          </a:p>
+        </p:txBody>
+      </p:sp>
+      <p:sp>
+        <p:nvSpPr>
+          <p:cNvPr id="19" name="Text 17"/>
+          <p:cNvSpPr txBox="1"/>
+          <p:nvPr/>
+        </p:nvSpPr>
+        <p:spPr>
+          <a:xfrm>
+            <a:off x="3566160" y="4361688"/>
+            <a:ext cx="2377440" cy="384048"/>
+          </a:xfrm>
+          <a:prstGeom prst="rect">
+            <a:avLst/>
+          </a:prstGeom>
+          <a:noFill/>
+          <a:ln/>
+        </p:spPr>
+        <p:txBody>
+          <a:bodyPr wrap="square" lIns="0" tIns="0" rIns="0" bIns="0" rtlCol="0" anchor="t"/>
+          <a:lstStyle/>
+          <a:p>
+            <a:pPr indent="0" marL="0">
+              <a:buNone/>
+            </a:pPr>
+            <a:r>
+              <a:rPr lang="en-US" sz="1050" i="1" dirty="0">
+                <a:solidFill>
+                  <a:srgbClr val="5B6475"/>
+                </a:solidFill>
+                <a:latin typeface="Calibri" pitchFamily="34" charset="0"/>
+                <a:ea typeface="Calibri" pitchFamily="34" charset="-122"/>
+                <a:cs typeface="Calibri" pitchFamily="34" charset="-120"/>
+              </a:rPr>
+              <a:t>Borrador editable; documento posteado inmutable</a:t>
+            </a:r>
+            <a:endParaRPr lang="en-US" sz="1050" dirty="0"/>
+          </a:p>
+        </p:txBody>
+      </p:sp>
+      <p:sp>
+        <p:nvSpPr>
+          <p:cNvPr id="20" name="Shape 18"/>
+          <p:cNvSpPr/>
+          <p:nvPr/>
+        </p:nvSpPr>
+        <p:spPr>
+          <a:xfrm>
+            <a:off x="6446520" y="1280160"/>
+            <a:ext cx="384048" cy="384048"/>
+          </a:xfrm>
+          <a:prstGeom prst="ellipse">
+            <a:avLst/>
+          </a:prstGeom>
+          <a:solidFill>
+            <a:srgbClr val="2155D9"/>
+          </a:solidFill>
+          <a:ln w="12700">
+            <a:solidFill>
+              <a:srgbClr val="2155D9"/>
+            </a:solidFill>
+            <a:prstDash val="solid"/>
+          </a:ln>
+        </p:spPr>
+      </p:sp>
+      <p:sp>
+        <p:nvSpPr>
+          <p:cNvPr id="21" name="Text 19"/>
+          <p:cNvSpPr txBox="1"/>
+          <p:nvPr/>
+        </p:nvSpPr>
+        <p:spPr>
+          <a:xfrm>
+            <a:off x="6446520" y="1280160"/>
+            <a:ext cx="384048" cy="384048"/>
+          </a:xfrm>
+          <a:prstGeom prst="rect">
+            <a:avLst/>
+          </a:prstGeom>
+          <a:noFill/>
+          <a:ln/>
+        </p:spPr>
+        <p:txBody>
+          <a:bodyPr wrap="square" lIns="0" tIns="0" rIns="0" bIns="0" rtlCol="0" anchor="ctr"/>
+          <a:lstStyle/>
+          <a:p>
+            <a:pPr algn="ctr" indent="0" marL="0">
+              <a:buNone/>
+            </a:pPr>
+            <a:r>
+              <a:rPr lang="en-US" sz="1300" b="1" dirty="0">
+                <a:solidFill>
+                  <a:srgbClr val="FFFFFF"/>
+                </a:solidFill>
+                <a:latin typeface="Calibri" pitchFamily="34" charset="0"/>
+                <a:ea typeface="Calibri" pitchFamily="34" charset="-122"/>
+                <a:cs typeface="Calibri" pitchFamily="34" charset="-120"/>
+              </a:rPr>
+              <a:t>1</a:t>
+            </a:r>
+            <a:endParaRPr lang="en-US" sz="1300" dirty="0"/>
+          </a:p>
+        </p:txBody>
+      </p:sp>
+      <p:sp>
+        <p:nvSpPr>
+          <p:cNvPr id="22" name="Text 20"/>
+          <p:cNvSpPr txBox="1"/>
+          <p:nvPr/>
+        </p:nvSpPr>
+        <p:spPr>
+          <a:xfrm>
+            <a:off x="6949440" y="1243584"/>
+            <a:ext cx="1737360" cy="274320"/>
+          </a:xfrm>
+          <a:prstGeom prst="rect">
+            <a:avLst/>
+          </a:prstGeom>
+          <a:noFill/>
+          <a:ln/>
+        </p:spPr>
+        <p:txBody>
+          <a:bodyPr wrap="square" lIns="0" tIns="0" rIns="0" bIns="0" rtlCol="0" anchor="ctr"/>
+          <a:lstStyle/>
+          <a:p>
+            <a:pPr indent="0" marL="0">
+              <a:buNone/>
+            </a:pPr>
+            <a:r>
+              <a:rPr lang="en-US" sz="1300" b="1" dirty="0">
+                <a:solidFill>
+                  <a:srgbClr val="14213D"/>
+                </a:solidFill>
+                <a:latin typeface="Calibri" pitchFamily="34" charset="0"/>
+                <a:ea typeface="Calibri" pitchFamily="34" charset="-122"/>
+                <a:cs typeface="Calibri" pitchFamily="34" charset="-120"/>
+              </a:rPr>
+              <a:t>PK</a:t>
+            </a:r>
+            <a:endParaRPr lang="en-US" sz="1300" dirty="0"/>
+          </a:p>
+        </p:txBody>
+      </p:sp>
+      <p:sp>
+        <p:nvSpPr>
+          <p:cNvPr id="23" name="Text 21"/>
+          <p:cNvSpPr txBox="1"/>
+          <p:nvPr/>
+        </p:nvSpPr>
+        <p:spPr>
+          <a:xfrm>
+            <a:off x="6949440" y="1517904"/>
+            <a:ext cx="1737360" cy="548640"/>
+          </a:xfrm>
+          <a:prstGeom prst="rect">
+            <a:avLst/>
+          </a:prstGeom>
+          <a:noFill/>
+          <a:ln/>
+        </p:spPr>
+        <p:txBody>
+          <a:bodyPr wrap="square" lIns="0" tIns="0" rIns="0" bIns="0" rtlCol="0" anchor="t"/>
+          <a:lstStyle/>
+          <a:p>
+            <a:pPr indent="0" marL="0">
+              <a:buNone/>
+            </a:pPr>
+            <a:r>
+              <a:rPr lang="en-US" sz="1050" dirty="0">
+                <a:solidFill>
+                  <a:srgbClr val="1F2937"/>
+                </a:solidFill>
+                <a:latin typeface="Calibri" pitchFamily="34" charset="0"/>
+                <a:ea typeface="Calibri" pitchFamily="34" charset="-122"/>
+                <a:cs typeface="Calibri" pitchFamily="34" charset="-120"/>
+              </a:rPr>
+              <a:t>uuid en maestros; Numero (texto) en documentos posteados; bigint en libros</a:t>
+            </a:r>
+            <a:endParaRPr lang="en-US" sz="1050" dirty="0"/>
+          </a:p>
+        </p:txBody>
+      </p:sp>
+      <p:sp>
+        <p:nvSpPr>
+          <p:cNvPr id="24" name="Shape 22"/>
+          <p:cNvSpPr/>
+          <p:nvPr/>
+        </p:nvSpPr>
+        <p:spPr>
+          <a:xfrm>
+            <a:off x="6446520" y="2148840"/>
+            <a:ext cx="384048" cy="384048"/>
+          </a:xfrm>
+          <a:prstGeom prst="ellipse">
+            <a:avLst/>
+          </a:prstGeom>
+          <a:solidFill>
+            <a:srgbClr val="2155D9"/>
+          </a:solidFill>
+          <a:ln w="12700">
+            <a:solidFill>
+              <a:srgbClr val="2155D9"/>
+            </a:solidFill>
+            <a:prstDash val="solid"/>
+          </a:ln>
+        </p:spPr>
+      </p:sp>
+      <p:sp>
+        <p:nvSpPr>
+          <p:cNvPr id="25" name="Text 23"/>
+          <p:cNvSpPr txBox="1"/>
+          <p:nvPr/>
+        </p:nvSpPr>
+        <p:spPr>
+          <a:xfrm>
+            <a:off x="6446520" y="2148840"/>
+            <a:ext cx="384048" cy="384048"/>
+          </a:xfrm>
+          <a:prstGeom prst="rect">
+            <a:avLst/>
+          </a:prstGeom>
+          <a:noFill/>
+          <a:ln/>
+        </p:spPr>
+        <p:txBody>
+          <a:bodyPr wrap="square" lIns="0" tIns="0" rIns="0" bIns="0" rtlCol="0" anchor="ctr"/>
+          <a:lstStyle/>
+          <a:p>
+            <a:pPr algn="ctr" indent="0" marL="0">
+              <a:buNone/>
+            </a:pPr>
+            <a:r>
+              <a:rPr lang="en-US" sz="1300" b="1" dirty="0">
+                <a:solidFill>
+                  <a:srgbClr val="FFFFFF"/>
+                </a:solidFill>
+                <a:latin typeface="Calibri" pitchFamily="34" charset="0"/>
+                <a:ea typeface="Calibri" pitchFamily="34" charset="-122"/>
+                <a:cs typeface="Calibri" pitchFamily="34" charset="-120"/>
+              </a:rPr>
+              <a:t>2</a:t>
+            </a:r>
+            <a:endParaRPr lang="en-US" sz="1300" dirty="0"/>
+          </a:p>
+        </p:txBody>
+      </p:sp>
+      <p:sp>
+        <p:nvSpPr>
+          <p:cNvPr id="26" name="Text 24"/>
+          <p:cNvSpPr txBox="1"/>
+          <p:nvPr/>
+        </p:nvSpPr>
+        <p:spPr>
+          <a:xfrm>
+            <a:off x="6949440" y="2112264"/>
+            <a:ext cx="1737360" cy="274320"/>
+          </a:xfrm>
+          <a:prstGeom prst="rect">
+            <a:avLst/>
+          </a:prstGeom>
+          <a:noFill/>
+          <a:ln/>
+        </p:spPr>
+        <p:txBody>
+          <a:bodyPr wrap="square" lIns="0" tIns="0" rIns="0" bIns="0" rtlCol="0" anchor="ctr"/>
+          <a:lstStyle/>
+          <a:p>
+            <a:pPr indent="0" marL="0">
+              <a:buNone/>
+            </a:pPr>
+            <a:r>
+              <a:rPr lang="en-US" sz="1300" b="1" dirty="0">
+                <a:solidFill>
+                  <a:srgbClr val="14213D"/>
+                </a:solidFill>
+                <a:latin typeface="Calibri" pitchFamily="34" charset="0"/>
+                <a:ea typeface="Calibri" pitchFamily="34" charset="-122"/>
+                <a:cs typeface="Calibri" pitchFamily="34" charset="-120"/>
+              </a:rPr>
+              <a:t>Importes</a:t>
+            </a:r>
+            <a:endParaRPr lang="en-US" sz="1300" dirty="0"/>
+          </a:p>
+        </p:txBody>
+      </p:sp>
+      <p:sp>
+        <p:nvSpPr>
+          <p:cNvPr id="27" name="Text 25"/>
+          <p:cNvSpPr txBox="1"/>
+          <p:nvPr/>
+        </p:nvSpPr>
+        <p:spPr>
+          <a:xfrm>
+            <a:off x="6949440" y="2386584"/>
+            <a:ext cx="1737360" cy="548640"/>
+          </a:xfrm>
+          <a:prstGeom prst="rect">
+            <a:avLst/>
+          </a:prstGeom>
+          <a:noFill/>
+          <a:ln/>
+        </p:spPr>
+        <p:txBody>
+          <a:bodyPr wrap="square" lIns="0" tIns="0" rIns="0" bIns="0" rtlCol="0" anchor="t"/>
+          <a:lstStyle/>
+          <a:p>
+            <a:pPr indent="0" marL="0">
+              <a:buNone/>
+            </a:pPr>
+            <a:r>
+              <a:rPr lang="en-US" sz="1050" dirty="0">
+                <a:solidFill>
+                  <a:srgbClr val="1F2937"/>
+                </a:solidFill>
+                <a:latin typeface="Calibri" pitchFamily="34" charset="0"/>
+                <a:ea typeface="Calibri" pitchFamily="34" charset="-122"/>
+                <a:cs typeface="Calibri" pitchFamily="34" charset="-120"/>
+              </a:rPr>
+              <a:t>numeric(18,4); cantidades numeric(18,6)</a:t>
+            </a:r>
+            <a:endParaRPr lang="en-US" sz="1050" dirty="0"/>
+          </a:p>
+        </p:txBody>
+      </p:sp>
+      <p:sp>
+        <p:nvSpPr>
+          <p:cNvPr id="28" name="Shape 26"/>
+          <p:cNvSpPr/>
+          <p:nvPr/>
+        </p:nvSpPr>
+        <p:spPr>
+          <a:xfrm>
+            <a:off x="6446520" y="3017520"/>
+            <a:ext cx="384048" cy="384048"/>
+          </a:xfrm>
+          <a:prstGeom prst="ellipse">
+            <a:avLst/>
+          </a:prstGeom>
+          <a:solidFill>
+            <a:srgbClr val="2155D9"/>
+          </a:solidFill>
+          <a:ln w="12700">
+            <a:solidFill>
+              <a:srgbClr val="2155D9"/>
+            </a:solidFill>
+            <a:prstDash val="solid"/>
+          </a:ln>
+        </p:spPr>
+      </p:sp>
+      <p:sp>
+        <p:nvSpPr>
+          <p:cNvPr id="29" name="Text 27"/>
+          <p:cNvSpPr txBox="1"/>
+          <p:nvPr/>
+        </p:nvSpPr>
+        <p:spPr>
+          <a:xfrm>
+            <a:off x="6446520" y="3017520"/>
+            <a:ext cx="384048" cy="384048"/>
+          </a:xfrm>
+          <a:prstGeom prst="rect">
+            <a:avLst/>
+          </a:prstGeom>
+          <a:noFill/>
+          <a:ln/>
+        </p:spPr>
+        <p:txBody>
+          <a:bodyPr wrap="square" lIns="0" tIns="0" rIns="0" bIns="0" rtlCol="0" anchor="ctr"/>
+          <a:lstStyle/>
+          <a:p>
+            <a:pPr algn="ctr" indent="0" marL="0">
+              <a:buNone/>
+            </a:pPr>
+            <a:r>
+              <a:rPr lang="en-US" sz="1300" b="1" dirty="0">
+                <a:solidFill>
+                  <a:srgbClr val="FFFFFF"/>
+                </a:solidFill>
+                <a:latin typeface="Calibri" pitchFamily="34" charset="0"/>
+                <a:ea typeface="Calibri" pitchFamily="34" charset="-122"/>
+                <a:cs typeface="Calibri" pitchFamily="34" charset="-120"/>
+              </a:rPr>
+              <a:t>3</a:t>
+            </a:r>
+            <a:endParaRPr lang="en-US" sz="1300" dirty="0"/>
+          </a:p>
+        </p:txBody>
+      </p:sp>
+      <p:sp>
+        <p:nvSpPr>
+          <p:cNvPr id="30" name="Text 28"/>
+          <p:cNvSpPr txBox="1"/>
+          <p:nvPr/>
+        </p:nvSpPr>
+        <p:spPr>
+          <a:xfrm>
+            <a:off x="6949440" y="2980944"/>
+            <a:ext cx="1737360" cy="274320"/>
+          </a:xfrm>
+          <a:prstGeom prst="rect">
+            <a:avLst/>
+          </a:prstGeom>
+          <a:noFill/>
+          <a:ln/>
+        </p:spPr>
+        <p:txBody>
+          <a:bodyPr wrap="square" lIns="0" tIns="0" rIns="0" bIns="0" rtlCol="0" anchor="ctr"/>
+          <a:lstStyle/>
+          <a:p>
+            <a:pPr indent="0" marL="0">
+              <a:buNone/>
+            </a:pPr>
+            <a:r>
+              <a:rPr lang="en-US" sz="1300" b="1" dirty="0">
+                <a:solidFill>
+                  <a:srgbClr val="14213D"/>
+                </a:solidFill>
+                <a:latin typeface="Calibri" pitchFamily="34" charset="0"/>
+                <a:ea typeface="Calibri" pitchFamily="34" charset="-122"/>
+                <a:cs typeface="Calibri" pitchFamily="34" charset="-120"/>
+              </a:rPr>
+              <a:t>Concurrencia</a:t>
+            </a:r>
+            <a:endParaRPr lang="en-US" sz="1300" dirty="0"/>
+          </a:p>
+        </p:txBody>
+      </p:sp>
+      <p:sp>
+        <p:nvSpPr>
+          <p:cNvPr id="31" name="Text 29"/>
+          <p:cNvSpPr txBox="1"/>
+          <p:nvPr/>
+        </p:nvSpPr>
+        <p:spPr>
+          <a:xfrm>
+            <a:off x="6949440" y="3255264"/>
+            <a:ext cx="1737360" cy="548640"/>
+          </a:xfrm>
+          <a:prstGeom prst="rect">
+            <a:avLst/>
+          </a:prstGeom>
+          <a:noFill/>
+          <a:ln/>
+        </p:spPr>
+        <p:txBody>
+          <a:bodyPr wrap="square" lIns="0" tIns="0" rIns="0" bIns="0" rtlCol="0" anchor="t"/>
+          <a:lstStyle/>
+          <a:p>
+            <a:pPr indent="0" marL="0">
+              <a:buNone/>
+            </a:pPr>
+            <a:r>
+              <a:rPr lang="en-US" sz="1050" dirty="0">
+                <a:solidFill>
+                  <a:srgbClr val="1F2937"/>
+                </a:solidFill>
+                <a:latin typeface="Calibri" pitchFamily="34" charset="0"/>
+                <a:ea typeface="Calibri" pitchFamily="34" charset="-122"/>
+                <a:cs typeface="Calibri" pitchFamily="34" charset="-120"/>
+              </a:rPr>
+              <a:t>xmin de PostgreSQL como token optimista</a:t>
+            </a:r>
+            <a:endParaRPr lang="en-US" sz="1050" dirty="0"/>
+          </a:p>
+        </p:txBody>
+      </p:sp>
+      <p:sp>
+        <p:nvSpPr>
+          <p:cNvPr id="32" name="Shape 30"/>
+          <p:cNvSpPr/>
+          <p:nvPr/>
+        </p:nvSpPr>
+        <p:spPr>
+          <a:xfrm>
+            <a:off x="6446520" y="3886200"/>
+            <a:ext cx="384048" cy="384048"/>
+          </a:xfrm>
+          <a:prstGeom prst="ellipse">
+            <a:avLst/>
+          </a:prstGeom>
+          <a:solidFill>
+            <a:srgbClr val="2155D9"/>
+          </a:solidFill>
+          <a:ln w="12700">
+            <a:solidFill>
+              <a:srgbClr val="2155D9"/>
+            </a:solidFill>
+            <a:prstDash val="solid"/>
+          </a:ln>
+        </p:spPr>
+      </p:sp>
+      <p:sp>
+        <p:nvSpPr>
+          <p:cNvPr id="33" name="Text 31"/>
+          <p:cNvSpPr txBox="1"/>
+          <p:nvPr/>
+        </p:nvSpPr>
+        <p:spPr>
+          <a:xfrm>
+            <a:off x="6446520" y="3886200"/>
+            <a:ext cx="384048" cy="384048"/>
+          </a:xfrm>
+          <a:prstGeom prst="rect">
+            <a:avLst/>
+          </a:prstGeom>
+          <a:noFill/>
+          <a:ln/>
+        </p:spPr>
+        <p:txBody>
+          <a:bodyPr wrap="square" lIns="0" tIns="0" rIns="0" bIns="0" rtlCol="0" anchor="ctr"/>
+          <a:lstStyle/>
+          <a:p>
+            <a:pPr algn="ctr" indent="0" marL="0">
+              <a:buNone/>
+            </a:pPr>
+            <a:r>
+              <a:rPr lang="en-US" sz="1300" b="1" dirty="0">
+                <a:solidFill>
+                  <a:srgbClr val="FFFFFF"/>
+                </a:solidFill>
+                <a:latin typeface="Calibri" pitchFamily="34" charset="0"/>
+                <a:ea typeface="Calibri" pitchFamily="34" charset="-122"/>
+                <a:cs typeface="Calibri" pitchFamily="34" charset="-120"/>
+              </a:rPr>
+              <a:t>4</a:t>
+            </a:r>
+            <a:endParaRPr lang="en-US" sz="1300" dirty="0"/>
+          </a:p>
+        </p:txBody>
+      </p:sp>
+      <p:sp>
+        <p:nvSpPr>
+          <p:cNvPr id="34" name="Text 32"/>
+          <p:cNvSpPr txBox="1"/>
+          <p:nvPr/>
+        </p:nvSpPr>
+        <p:spPr>
+          <a:xfrm>
+            <a:off x="6949440" y="3849624"/>
+            <a:ext cx="1737360" cy="274320"/>
+          </a:xfrm>
+          <a:prstGeom prst="rect">
+            <a:avLst/>
+          </a:prstGeom>
+          <a:noFill/>
+          <a:ln/>
+        </p:spPr>
+        <p:txBody>
+          <a:bodyPr wrap="square" lIns="0" tIns="0" rIns="0" bIns="0" rtlCol="0" anchor="ctr"/>
+          <a:lstStyle/>
+          <a:p>
+            <a:pPr indent="0" marL="0">
+              <a:buNone/>
+            </a:pPr>
+            <a:r>
+              <a:rPr lang="en-US" sz="1300" b="1" dirty="0">
+                <a:solidFill>
+                  <a:srgbClr val="14213D"/>
+                </a:solidFill>
+                <a:latin typeface="Calibri" pitchFamily="34" charset="0"/>
+                <a:ea typeface="Calibri" pitchFamily="34" charset="-122"/>
+                <a:cs typeface="Calibri" pitchFamily="34" charset="-120"/>
+              </a:rPr>
+              <a:t>Detalle</a:t>
+            </a:r>
+            <a:endParaRPr lang="en-US" sz="1300" dirty="0"/>
+          </a:p>
+        </p:txBody>
+      </p:sp>
+      <p:sp>
+        <p:nvSpPr>
+          <p:cNvPr id="35" name="Text 33"/>
+          <p:cNvSpPr txBox="1"/>
+          <p:nvPr/>
+        </p:nvSpPr>
+        <p:spPr>
+          <a:xfrm>
+            <a:off x="6949440" y="4123944"/>
+            <a:ext cx="1737360" cy="548640"/>
+          </a:xfrm>
+          <a:prstGeom prst="rect">
+            <a:avLst/>
+          </a:prstGeom>
+          <a:noFill/>
+          <a:ln/>
+        </p:spPr>
+        <p:txBody>
+          <a:bodyPr wrap="square" lIns="0" tIns="0" rIns="0" bIns="0" rtlCol="0" anchor="t"/>
+          <a:lstStyle/>
+          <a:p>
+            <a:pPr indent="0" marL="0">
+              <a:buNone/>
+            </a:pPr>
+            <a:r>
+              <a:rPr lang="en-US" sz="1050" dirty="0">
+                <a:solidFill>
+                  <a:srgbClr val="1F2937"/>
+                </a:solidFill>
+                <a:latin typeface="Calibri" pitchFamily="34" charset="0"/>
+                <a:ea typeface="Calibri" pitchFamily="34" charset="-122"/>
+                <a:cs typeface="Calibri" pitchFamily="34" charset="-120"/>
+              </a:rPr>
+              <a:t>Seis vistas ER por dominio y diccionario de datos en el documento (§4)</a:t>
+            </a:r>
+            <a:endParaRPr lang="en-US" sz="1050" dirty="0"/>
           </a:p>
         </p:txBody>
       </p:sp>

</xml_diff>